<commit_message>
PythonBasics: clearer error messages (where + what); consistent f-string example
Co-Authored-By: Claude Fable 5.1 <noreply@anthropic.com>
Claude-Session: https://claude.ai/code/session_01XfFe4wSXBfWkpyngQQESYX
</commit_message>
<xml_diff>
--- a/bap/Week3/BAP_Week3_Python_Basics.pptx
+++ b/bap/Week3/BAP_Week3_Python_Basics.pptx
@@ -11776,7 +11776,7 @@
                 </a:solidFill>
                 <a:latin typeface="Courier New"/>
               </a:rPr>
-              <a:t>share = 0.2345</a:t>
+              <a:t>share = 0.24</a:t>
             </a:r>
           </a:p>
           <a:p>
@@ -12023,7 +12023,7 @@
                 </a:solidFill>
                 <a:latin typeface="Courier New"/>
               </a:rPr>
-              <a:t>Market share: 23.5%</a:t>
+              <a:t>Market share: 24.0%</a:t>
             </a:r>
           </a:p>
         </p:txBody>

</xml_diff>

<commit_message>
Week 3: e-shop examples throughout (products, monthly sales, customers); user's new title slide
Co-Authored-By: Claude Fable 5.1 <noreply@anthropic.com>
Claude-Session: https://claude.ai/code/session_01XfFe4wSXBfWkpyngQQESYX
</commit_message>
<xml_diff>
--- a/bap/Week3/BAP_Week3_Python_Basics.pptx
+++ b/bap/Week3/BAP_Week3_Python_Basics.pptx
@@ -898,7 +898,7 @@
           <a:lstStyle/>
           <a:p>
             <a:r>
-              <a:t>Για να ενώσουμε αριθμό με κείμενο, μετατρέπουμε τον αριθμό σε string με str(). Αντίστοιχα int(), float(), bool().</a:t>
+              <a:t>Για να ενώσουμε αριθμό με κείμενο, μετατρέπουμε τον αριθμό σε string με str(). Αντίστοιχα int(), float(), bool(). Παράδειγμα: έσοδα 1250 με 8% ετήσια αύξηση για 5 χρόνια.</a:t>
             </a:r>
           </a:p>
         </p:txBody>
@@ -1108,7 +1108,7 @@
           <a:lstStyle/>
           <a:p>
             <a:r>
-              <a:t>Κάθε μεταβλητή κρατά μία τιμή. Για πολλές τιμές (π.χ. τα εμβαδά των δωματίων ενός σπιτιού) χρειαζόμαστε μια δομή που τις κρατά όλες μαζί: τη λίστα.</a:t>
+              <a:t>Κάθε μεταβλητή κρατά μία τιμή. Για πολλές τιμές (π.χ. τις μηνιαίες πωλήσεις ενός καταστήματος) χρειαζόμαστε μια δομή που τις κρατά όλες μαζί: τη λίστα.</a:t>
             </a:r>
           </a:p>
         </p:txBody>
@@ -1178,7 +1178,7 @@
           <a:lstStyle/>
           <a:p>
             <a:r>
-              <a:t>Μια λίστα μπορεί να περιέχει οποιονδήποτε τύπο, ακόμη και μείγμα τύπων, αν και δεν είναι συνηθισμένο. Εδώ: ονόματα (str) και εμβαδά (float) εναλλάξ. Ο τύπος της ίδιας της λίστας είναι list.</a:t>
+              <a:t>Μια λίστα μπορεί να περιέχει οποιονδήποτε τύπο, ακόμη και μείγμα τύπων, αν και δεν είναι συνηθισμένο. Εδώ: ονόματα προϊόντων (str) και τιμές (float) εναλλάξ. Ο τύπος της ίδιας της λίστας είναι list.</a:t>
             </a:r>
           </a:p>
         </p:txBody>
@@ -1528,7 +1528,7 @@
           <a:lstStyle/>
           <a:p>
             <a:r>
-              <a:t>Λύση: areas[1] → 11.25 (το δεύτερο στοιχείο), areas[-1] → 9.5 (το τελευταίο), areas[5] → 20.0 (το έκτο, το εμβαδό του living room).</a:t>
+              <a:t>Λύση: products[1] → 899.0 (το δεύτερο στοιχείο), products[-1] → 59.0 (το τελευταίο), products[5] → 249.0 (το έκτο, η τιμή του monitor).</a:t>
             </a:r>
           </a:p>
         </p:txBody>
@@ -1738,7 +1738,7 @@
           <a:lstStyle/>
           <a:p>
             <a:r>
-              <a:t>Από τη λίστα areas (10 στοιχεία) φτιάξε downstairs με τα 6 πρώτα και upstairs με τα 4 τελευταία. Δύο γραφές: με όρια και χωρίς.</a:t>
+              <a:t>Από τη λίστα sales (12 μήνες) φτιάξε h1 με τους 6 πρώτους μήνες και h2 με τους 6 τελευταίους. Δύο γραφές: με όρια και χωρίς.</a:t>
             </a:r>
           </a:p>
         </p:txBody>
@@ -1808,7 +1808,7 @@
           <a:lstStyle/>
           <a:p>
             <a:r>
-              <a:t>x[2] επιστρέφει λίστα, οπότε μπορούμε να βάλουμε κι άλλες αγκύλες: x[2][0]. Διαβάζεται από αριστερά προς τα δεξιά: πρώτα η γραμμή, μετά η στήλη.</a:t>
+              <a:t>sales[2] επιστρέφει λίστα, οπότε μπορούμε να βάλουμε κι άλλες αγκύλες: sales[2][0]. Διαβάζεται από αριστερά προς τα δεξιά: πρώτα η γραμμή (τρίμηνο), μετά η στήλη (μήνας).</a:t>
             </a:r>
           </a:p>
         </p:txBody>
@@ -2018,7 +2018,7 @@
           <a:lstStyle/>
           <a:p>
             <a:r>
-              <a:t>Προσθήκη. y = x δεν αντιγράφει τη λίστα, δίνει δεύτερο όνομα στην ίδια λίστα. Για πραγματικό αντίγραφο: list(x) ή x[:].</a:t>
+              <a:t>Προσθήκη. backup = sales δεν αντιγράφει τη λίστα, δίνει δεύτερο όνομα στην ίδια λίστα. Για πραγματικό αντίγραφο: list(x) ή x[:].</a:t>
             </a:r>
           </a:p>
         </p:txBody>
@@ -2298,7 +2298,7 @@
           <a:lstStyle/>
           <a:p>
             <a:r>
-              <a:t>Συνδυασμός συναρτήσεων: η έξοδος της μίας γίνεται είσοδος της άλλης (print(type(var1))).</a:t>
+              <a:t>Συνδυασμός συναρτήσεων: η έξοδος της μίας γίνεται είσοδος της άλλης (print(type(orders))).</a:t>
             </a:r>
           </a:p>
         </p:txBody>
@@ -2438,7 +2438,7 @@
           <a:lstStyle/>
           <a:p>
             <a:r>
-              <a:t>Κάθε τιμή στην Python είναι αντικείμενο (object) και κάθε τύπος έχει τις δικές του μεθόδους. Καλούνται με τελεία: αντικείμενο.μέθοδος().</a:t>
+              <a:t>Κάθε τιμή στην Python είναι αντικείμενο (object) και κάθε τύπος έχει τις δικές του μεθόδους. Καλούνται με τελεία: city.upper(), customers.index("nikos").</a:t>
             </a:r>
           </a:p>
         </p:txBody>
@@ -2508,7 +2508,7 @@
           <a:lstStyle/>
           <a:p>
             <a:r>
-              <a:t>Προσοχή: κάποιες μέθοδοι αλλάζουν το αντικείμενο (append, remove, reverse), ενώ άλλες επιστρέφουν νέα τιμή (upper). Το fam.append("x") δεν επιστρέφει τίποτα· η αλλαγή έγινε μέσα στη fam.</a:t>
+              <a:t>Προσοχή: κάποιες μέθοδοι αλλάζουν το αντικείμενο (append, remove, reverse), ενώ άλλες επιστρέφουν νέα τιμή (upper). Το customers.append("maria") δεν επιστρέφει τίποτα· η αλλαγή έγινε μέσα στη customers.</a:t>
             </a:r>
           </a:p>
         </p:txBody>
@@ -3068,7 +3068,7 @@
           <a:lstStyle/>
           <a:p>
             <a:r>
-              <a:t>Μια μεταβλητή είναι ένα όνομα που δείχνει σε μια τιμή. Case-sensitive: savings και Savings είναι διαφορετικές.</a:t>
+              <a:t>Μια μεταβλητή είναι ένα όνομα που δείχνει σε μια τιμή. Case-sensitive: revenue και Revenue είναι διαφορετικές.</a:t>
             </a:r>
           </a:p>
         </p:txBody>
@@ -3138,7 +3138,7 @@
           <a:lstStyle/>
           <a:p>
             <a:r>
-              <a:t>Αν θέλουμε να ξανατρέξουμε τον υπολογισμό για άλλον αριθμό μηνών, αλλάζουμε μόνο τη δήλωση της μεταβλητής και ξανατρέχουμε το script.</a:t>
+              <a:t>Αν θέλουμε να ξανατρέξουμε τον υπολογισμό για άλλη ποσότητα, αλλάζουμε μόνο τη δήλωση της μεταβλητής και ξανατρέχουμε το script.</a:t>
             </a:r>
           </a:p>
         </p:txBody>
@@ -3616,9 +3616,38 @@
           </a:p>
         </p:txBody>
       </p:sp>
+      <p:sp>
+        <p:nvSpPr>
+          <p:cNvPr id="13" name="Shape 13"/>
+          <p:cNvSpPr/>
+          <p:nvPr userDrawn="1"/>
+        </p:nvSpPr>
+        <p:spPr>
+          <a:xfrm>
+            <a:off x="2971800" y="7591425"/>
+            <a:ext cx="9525" cy="657225"/>
+          </a:xfrm>
+          <a:prstGeom prst="rect">
+            <a:avLst/>
+          </a:prstGeom>
+          <a:solidFill>
+            <a:srgbClr val="DDE2F5"/>
+          </a:solidFill>
+          <a:ln>
+            <a:noFill/>
+          </a:ln>
+        </p:spPr>
+        <p:txBody>
+          <a:bodyPr/>
+          <a:lstStyle/>
+          <a:p>
+            <a:endParaRPr lang="en-US"/>
+          </a:p>
+        </p:txBody>
+      </p:sp>
       <p:pic>
         <p:nvPicPr>
-          <p:cNvPr id="12" name="Picture 12"/>
+          <p:cNvPr id="14" name="Picture 14"/>
           <p:cNvPicPr>
             <a:picLocks noChangeAspect="1"/>
           </p:cNvPicPr>
@@ -3632,59 +3661,6 @@
         </p:blipFill>
         <p:spPr>
           <a:xfrm>
-            <a:off x="1647825" y="7467600"/>
-            <a:ext cx="971550" cy="914400"/>
-          </a:xfrm>
-          <a:prstGeom prst="rect">
-            <a:avLst/>
-          </a:prstGeom>
-        </p:spPr>
-      </p:pic>
-      <p:sp>
-        <p:nvSpPr>
-          <p:cNvPr id="13" name="Shape 13"/>
-          <p:cNvSpPr/>
-          <p:nvPr userDrawn="1"/>
-        </p:nvSpPr>
-        <p:spPr>
-          <a:xfrm>
-            <a:off x="2971800" y="7591425"/>
-            <a:ext cx="9525" cy="657225"/>
-          </a:xfrm>
-          <a:prstGeom prst="rect">
-            <a:avLst/>
-          </a:prstGeom>
-          <a:solidFill>
-            <a:srgbClr val="DDE2F5"/>
-          </a:solidFill>
-          <a:ln>
-            <a:noFill/>
-          </a:ln>
-        </p:spPr>
-        <p:txBody>
-          <a:bodyPr/>
-          <a:lstStyle/>
-          <a:p>
-            <a:endParaRPr lang="en-US"/>
-          </a:p>
-        </p:txBody>
-      </p:sp>
-      <p:pic>
-        <p:nvPicPr>
-          <p:cNvPr id="14" name="Picture 14"/>
-          <p:cNvPicPr>
-            <a:picLocks noChangeAspect="1"/>
-          </p:cNvPicPr>
-          <p:nvPr userDrawn="1"/>
-        </p:nvPicPr>
-        <p:blipFill rotWithShape="1">
-          <a:blip r:embed="rId4"/>
-          <a:stretch>
-            <a:fillRect/>
-          </a:stretch>
-        </p:blipFill>
-        <p:spPr>
-          <a:xfrm>
             <a:off x="3343275" y="7591425"/>
             <a:ext cx="2095500" cy="657225"/>
           </a:xfrm>
@@ -3731,7 +3707,7 @@
           <p:nvPr userDrawn="1"/>
         </p:nvPicPr>
         <p:blipFill rotWithShape="1">
-          <a:blip r:embed="rId5"/>
+          <a:blip r:embed="rId4"/>
           <a:stretch>
             <a:fillRect/>
           </a:stretch>
@@ -7761,7 +7737,7 @@
 </file>
 
 <file path=ppt/slides/slide1.xml><?xml version="1.0" encoding="utf-8"?>
-<p:sld xmlns:a="http://schemas.openxmlformats.org/drawingml/2006/main" xmlns:p="http://schemas.openxmlformats.org/presentationml/2006/main" xmlns:r="http://schemas.openxmlformats.org/officeDocument/2006/relationships">
+<p:sld xmlns:a="http://schemas.openxmlformats.org/drawingml/2006/main" xmlns:r="http://schemas.openxmlformats.org/officeDocument/2006/relationships" xmlns:p="http://schemas.openxmlformats.org/presentationml/2006/main">
   <p:cSld>
     <p:spTree>
       <p:nvGrpSpPr>
@@ -7769,7 +7745,14 @@
         <p:cNvGrpSpPr/>
         <p:nvPr/>
       </p:nvGrpSpPr>
-      <p:grpSpPr/>
+      <p:grpSpPr>
+        <a:xfrm>
+          <a:off x="0" y="0"/>
+          <a:ext cx="0" cy="0"/>
+          <a:chOff x="0" y="0"/>
+          <a:chExt cx="0" cy="0"/>
+        </a:xfrm>
+      </p:grpSpPr>
       <p:sp>
         <p:nvSpPr>
           <p:cNvPr id="2" name="Title 1"/>
@@ -7780,14 +7763,23 @@
             <p:ph type="ctrTitle"/>
           </p:nvPr>
         </p:nvSpPr>
-        <p:spPr/>
-        <p:txBody>
-          <a:bodyPr/>
-          <a:lstStyle/>
-          <a:p>
-            <a:r>
-              <a:t>Εισαγωγή στην Python</a:t>
-            </a:r>
+        <p:spPr>
+          <a:xfrm>
+            <a:off x="1581150" y="2322740"/>
+            <a:ext cx="9153525" cy="2190750"/>
+          </a:xfrm>
+        </p:spPr>
+        <p:txBody>
+          <a:bodyPr>
+            <a:noAutofit/>
+          </a:bodyPr>
+          <a:lstStyle/>
+          <a:p>
+            <a:r>
+              <a:rPr lang="el-GR" sz="5400" dirty="0"/>
+              <a:t>Προγραμματισμός για Επιχειρηματική Αναλυτική</a:t>
+            </a:r>
+            <a:endParaRPr sz="5400" dirty="0"/>
           </a:p>
         </p:txBody>
       </p:sp>
@@ -7801,14 +7793,57 @@
             <p:ph type="subTitle" idx="1"/>
           </p:nvPr>
         </p:nvSpPr>
-        <p:spPr/>
-        <p:txBody>
-          <a:bodyPr/>
-          <a:lstStyle/>
-          <a:p>
-            <a:r>
-              <a:rPr sz="2000"/>
-              <a:t>Προγραμματισμός για Επιχειρηματική Αναλυτική · Εβδομάδα 3</a:t>
+        <p:spPr>
+          <a:xfrm>
+            <a:off x="1581150" y="4642757"/>
+            <a:ext cx="9086850" cy="571500"/>
+          </a:xfrm>
+        </p:spPr>
+        <p:txBody>
+          <a:bodyPr>
+            <a:normAutofit/>
+          </a:bodyPr>
+          <a:lstStyle/>
+          <a:p>
+            <a:r>
+              <a:rPr lang="el-GR" sz="2800" dirty="0" err="1"/>
+              <a:t>Εισαγωγ</a:t>
+            </a:r>
+            <a:r>
+              <a:rPr lang="en-US" sz="2800" dirty="0" err="1"/>
+              <a:t>ή</a:t>
+            </a:r>
+            <a:r>
+              <a:rPr lang="el-GR" sz="2800" dirty="0"/>
+              <a:t> στην </a:t>
+            </a:r>
+            <a:r>
+              <a:rPr lang="en-US" sz="2800" dirty="0"/>
+              <a:t>Python</a:t>
+            </a:r>
+            <a:r>
+              <a:rPr lang="el-GR" sz="2800" dirty="0"/>
+              <a:t> -</a:t>
+            </a:r>
+            <a:r>
+              <a:rPr sz="2800" dirty="0"/>
+              <a:t> </a:t>
+            </a:r>
+            <a:r>
+              <a:rPr sz="2800" dirty="0" err="1"/>
+              <a:t>Ε</a:t>
+            </a:r>
+            <a:r>
+              <a:rPr sz="2800" dirty="0"/>
+              <a:t>β</a:t>
+            </a:r>
+            <a:r>
+              <a:rPr sz="2800" dirty="0" err="1"/>
+              <a:t>δομάδ</a:t>
+            </a:r>
+            <a:r>
+              <a:rPr sz="2800" dirty="0"/>
+              <a:t>α 3</a:t>
             </a:r>
           </a:p>
         </p:txBody>
@@ -7829,8 +7864,42 @@
           <a:lstStyle/>
           <a:p>
             <a:r>
-              <a:t>Ευάγγελος Καλαμπόκης</a:t>
-            </a:r>
+              <a:rPr dirty="0" err="1"/>
+              <a:t>Ευάγγελος</a:t>
+            </a:r>
+            <a:r>
+              <a:rPr dirty="0"/>
+              <a:t> </a:t>
+            </a:r>
+            <a:r>
+              <a:rPr dirty="0" err="1"/>
+              <a:t>Κ</a:t>
+            </a:r>
+            <a:r>
+              <a:rPr dirty="0"/>
+              <a:t>α</a:t>
+            </a:r>
+            <a:r>
+              <a:rPr dirty="0" err="1"/>
+              <a:t>λ</a:t>
+            </a:r>
+            <a:r>
+              <a:rPr dirty="0"/>
+              <a:t>α</a:t>
+            </a:r>
+            <a:r>
+              <a:rPr dirty="0" err="1"/>
+              <a:t>μ</a:t>
+            </a:r>
+            <a:r>
+              <a:rPr dirty="0"/>
+              <a:t>π</a:t>
+            </a:r>
+            <a:r>
+              <a:rPr dirty="0" err="1"/>
+              <a:t>όκης</a:t>
+            </a:r>
+            <a:endParaRPr dirty="0"/>
           </a:p>
         </p:txBody>
       </p:sp>
@@ -7850,8 +7919,12 @@
           <a:lstStyle/>
           <a:p>
             <a:r>
+              <a:rPr dirty="0" err="1">
+                <a:hlinkClick r:id="rId3"/>
+              </a:rPr>
               <a:t>kalampokis.github.io</a:t>
             </a:r>
+            <a:endParaRPr dirty="0"/>
           </a:p>
         </p:txBody>
       </p:sp>
@@ -8202,7 +8275,7 @@
                 </a:solidFill>
                 <a:latin typeface="Courier New"/>
               </a:rPr>
-              <a:t>savings = 100</a:t>
+              <a:t>revenue = 1250</a:t>
             </a:r>
           </a:p>
           <a:p>
@@ -8235,7 +8308,7 @@
                 </a:solidFill>
                 <a:latin typeface="Courier New"/>
               </a:rPr>
-              <a:t>print(savings)</a:t>
+              <a:t>print(revenue)</a:t>
             </a:r>
           </a:p>
         </p:txBody>
@@ -8361,7 +8434,7 @@
                 </a:solidFill>
                 <a:latin typeface="Courier New"/>
               </a:rPr>
-              <a:t>100</a:t>
+              <a:t>1250</a:t>
             </a:r>
           </a:p>
         </p:txBody>
@@ -8605,7 +8678,7 @@
                 </a:solidFill>
                 <a:latin typeface="Arial"/>
               </a:rPr>
-              <a:t>monthly_savings αντί για x. Μικρά γράμματα, λέξεις χωρισμένες με κάτω παύλα, χωρίς κενά ή ελληνικά.</a:t>
+              <a:t>unit_price αντί για x. Μικρά γράμματα, λέξεις χωρισμένες με κάτω παύλα, χωρίς κενά ή ελληνικά.</a:t>
             </a:r>
           </a:p>
         </p:txBody>
@@ -8678,7 +8751,7 @@
             <a:pPr lvl="1"/>
             <a:r>
               <a:rPr sz="1900"/>
-              <a:t>Ο κώδικας διαβάζεται σαν πρόταση: «οι συνολικές αποταμιεύσεις είναι οι μηνιαίες επί τους μήνες»</a:t>
+              <a:t>Ο κώδικας διαβάζεται σαν πρόταση: «το σύνολο είναι η τιμή επί την ποσότητα»</a:t>
             </a:r>
           </a:p>
           <a:p>
@@ -8696,7 +8769,7 @@
             <a:pPr lvl="1"/>
             <a:r>
               <a:rPr sz="1900"/>
-              <a:t>Θέλεις 24 μήνες; Αλλάζεις μόνο το num_months και ξανατρέχεις</a:t>
+              <a:t>Θέλεις 24 τεμάχια; Αλλάζεις μόνο το quantity και ξανατρέχεις</a:t>
             </a:r>
           </a:p>
           <a:p>
@@ -8719,11 +8792,11 @@
                 </a:solidFill>
                 <a:latin typeface="Courier New"/>
               </a:rPr>
-              <a:t>savings = savings + 50</a:t>
+              <a:t>stock = stock - 1</a:t>
             </a:r>
             <a:r>
               <a:rPr sz="1900"/>
-              <a:t>  προσθέτει 50 στην τρέχουσα τιμή</a:t>
+              <a:t>  αφαιρεί 1 από την τρέχουσα τιμή</a:t>
             </a:r>
           </a:p>
         </p:txBody>
@@ -8858,7 +8931,7 @@
                 </a:solidFill>
                 <a:latin typeface="Courier New"/>
               </a:rPr>
-              <a:t>monthly_savings = 10</a:t>
+              <a:t>unit_price = 25.5</a:t>
             </a:r>
           </a:p>
           <a:p>
@@ -8869,7 +8942,7 @@
                 </a:solidFill>
                 <a:latin typeface="Courier New"/>
               </a:rPr>
-              <a:t>num_months = 12</a:t>
+              <a:t>quantity = 12</a:t>
             </a:r>
           </a:p>
           <a:p>
@@ -8902,7 +8975,7 @@
                 </a:solidFill>
                 <a:latin typeface="Courier New"/>
               </a:rPr>
-              <a:t>new_savings = monthly_savings * num_months</a:t>
+              <a:t>total = unit_price * quantity</a:t>
             </a:r>
           </a:p>
           <a:p>
@@ -8935,7 +9008,7 @@
                 </a:solidFill>
                 <a:latin typeface="Courier New"/>
               </a:rPr>
-              <a:t>print(new_savings)</a:t>
+              <a:t>print(total)</a:t>
             </a:r>
           </a:p>
         </p:txBody>
@@ -9061,7 +9134,7 @@
                 </a:solidFill>
                 <a:latin typeface="Courier New"/>
               </a:rPr>
-              <a:t>120</a:t>
+              <a:t>306.0</a:t>
             </a:r>
           </a:p>
         </p:txBody>
@@ -9306,7 +9379,7 @@
                 </a:solidFill>
                 <a:latin typeface="Courier New"/>
               </a:rPr>
-              <a:t>x = 42</a:t>
+              <a:t>stock = 42</a:t>
             </a:r>
           </a:p>
         </p:txBody>
@@ -9512,7 +9585,7 @@
                 </a:solidFill>
                 <a:latin typeface="Courier New"/>
               </a:rPr>
-              <a:t>y = 1.75</a:t>
+              <a:t>price = 25.5</a:t>
             </a:r>
           </a:p>
         </p:txBody>
@@ -9718,7 +9791,7 @@
                 </a:solidFill>
                 <a:latin typeface="Courier New"/>
               </a:rPr>
-              <a:t>name = "Maria"</a:t>
+              <a:t>product = "Laptop"</a:t>
             </a:r>
           </a:p>
         </p:txBody>
@@ -9924,7 +9997,7 @@
                 </a:solidFill>
                 <a:latin typeface="Courier New"/>
               </a:rPr>
-              <a:t>ok = True</a:t>
+              <a:t>in_stock = True</a:t>
             </a:r>
           </a:p>
         </p:txBody>
@@ -10002,7 +10075,7 @@
             <a:pPr lvl="1"/>
             <a:r>
               <a:rPr sz="1900"/>
-              <a:t>Δουλεύει και με μεταβλητές: type(savings)</a:t>
+              <a:t>Δουλεύει και με μεταβλητές: type(revenue)</a:t>
             </a:r>
           </a:p>
           <a:p>
@@ -10158,7 +10231,7 @@
                 </a:solidFill>
                 <a:latin typeface="Courier New"/>
               </a:rPr>
-              <a:t>savings = 100</a:t>
+              <a:t>stock = 42</a:t>
             </a:r>
           </a:p>
           <a:p>
@@ -10169,7 +10242,7 @@
                 </a:solidFill>
                 <a:latin typeface="Courier New"/>
               </a:rPr>
-              <a:t>height = 1.79</a:t>
+              <a:t>price = 25.5</a:t>
             </a:r>
           </a:p>
           <a:p>
@@ -10180,7 +10253,7 @@
                 </a:solidFill>
                 <a:latin typeface="Courier New"/>
               </a:rPr>
-              <a:t>name = "Maria"</a:t>
+              <a:t>product = "Laptop"</a:t>
             </a:r>
           </a:p>
           <a:p>
@@ -10191,7 +10264,7 @@
                 </a:solidFill>
                 <a:latin typeface="Courier New"/>
               </a:rPr>
-              <a:t>ok = True</a:t>
+              <a:t>in_stock = True</a:t>
             </a:r>
           </a:p>
           <a:p>
@@ -10213,7 +10286,7 @@
                 </a:solidFill>
                 <a:latin typeface="Courier New"/>
               </a:rPr>
-              <a:t>print(type(savings))</a:t>
+              <a:t>print(type(stock))</a:t>
             </a:r>
           </a:p>
           <a:p>
@@ -10224,7 +10297,7 @@
                 </a:solidFill>
                 <a:latin typeface="Courier New"/>
               </a:rPr>
-              <a:t>print(type(height))</a:t>
+              <a:t>print(type(price))</a:t>
             </a:r>
           </a:p>
           <a:p>
@@ -10235,7 +10308,7 @@
                 </a:solidFill>
                 <a:latin typeface="Courier New"/>
               </a:rPr>
-              <a:t>print(type(name))</a:t>
+              <a:t>print(type(product))</a:t>
             </a:r>
           </a:p>
           <a:p>
@@ -10246,7 +10319,7 @@
                 </a:solidFill>
                 <a:latin typeface="Courier New"/>
               </a:rPr>
-              <a:t>print(type(ok))</a:t>
+              <a:t>print(type(in_stock))</a:t>
             </a:r>
           </a:p>
         </p:txBody>
@@ -11093,7 +11166,7 @@
         <p:spPr>
           <a:xfrm>
             <a:off x="9692640" y="2743200"/>
-            <a:ext cx="7452360" cy="4674870"/>
+            <a:ext cx="7452360" cy="5029200"/>
           </a:xfrm>
           <a:prstGeom prst="roundRect">
             <a:avLst>
@@ -11183,7 +11256,7 @@
         <p:spPr>
           <a:xfrm>
             <a:off x="9966960" y="3200400"/>
-            <a:ext cx="6903720" cy="4126230"/>
+            <a:ext cx="6903720" cy="4480560"/>
           </a:xfrm>
           <a:prstGeom prst="rect">
             <a:avLst/>
@@ -11203,7 +11276,7 @@
                 </a:solidFill>
                 <a:latin typeface="Courier New"/>
               </a:rPr>
-              <a:t>savings = 100</a:t>
+              <a:t>revenue = 1250</a:t>
             </a:r>
           </a:p>
           <a:p>
@@ -11214,7 +11287,7 @@
                 </a:solidFill>
                 <a:latin typeface="Courier New"/>
               </a:rPr>
-              <a:t>result = savings * 1.1 ** 7</a:t>
+              <a:t>growth = 1.08</a:t>
             </a:r>
           </a:p>
           <a:p>
@@ -11225,6 +11298,17 @@
                 </a:solidFill>
                 <a:latin typeface="Courier New"/>
               </a:rPr>
+              <a:t>result = revenue * growth ** 5</a:t>
+            </a:r>
+          </a:p>
+          <a:p>
+            <a:r>
+              <a:rPr sz="1800">
+                <a:solidFill>
+                  <a:srgbClr val="F4F6FF"/>
+                </a:solidFill>
+                <a:latin typeface="Courier New"/>
+              </a:rPr>
               <a:t> </a:t>
             </a:r>
           </a:p>
@@ -11247,7 +11331,7 @@
                 </a:solidFill>
                 <a:latin typeface="Courier New"/>
               </a:rPr>
-              <a:t>print("I started with $" + str(savings))</a:t>
+              <a:t>print("Revenue now: " + str(revenue))</a:t>
             </a:r>
           </a:p>
           <a:p>
@@ -11258,7 +11342,7 @@
                 </a:solidFill>
                 <a:latin typeface="Courier New"/>
               </a:rPr>
-              <a:t>print("Now I have $" + str(round(result)))</a:t>
+              <a:t>print("In 5 years: " + str(round(result)))</a:t>
             </a:r>
           </a:p>
           <a:p>
@@ -11291,7 +11375,7 @@
                 </a:solidFill>
                 <a:latin typeface="Courier New"/>
               </a:rPr>
-              <a:t>pi_string = "3.1415926"</a:t>
+              <a:t>stock_string = "42"</a:t>
             </a:r>
           </a:p>
           <a:p>
@@ -11302,7 +11386,7 @@
                 </a:solidFill>
                 <a:latin typeface="Courier New"/>
               </a:rPr>
-              <a:t>pi_float = float(pi_string)</a:t>
+              <a:t>stock = int(stock_string)</a:t>
             </a:r>
           </a:p>
           <a:p>
@@ -11313,7 +11397,7 @@
                 </a:solidFill>
                 <a:latin typeface="Courier New"/>
               </a:rPr>
-              <a:t>print(pi_float * 2)</a:t>
+              <a:t>print(stock - 1)</a:t>
             </a:r>
           </a:p>
         </p:txBody>
@@ -11326,7 +11410,7 @@
         </p:nvSpPr>
         <p:spPr>
           <a:xfrm>
-            <a:off x="9692640" y="7555230"/>
+            <a:off x="9692640" y="7909560"/>
             <a:ext cx="7452360" cy="1748790"/>
           </a:xfrm>
           <a:prstGeom prst="roundRect">
@@ -11383,7 +11467,7 @@
         </p:nvSpPr>
         <p:spPr>
           <a:xfrm>
-            <a:off x="9966960" y="7646670"/>
+            <a:off x="9966960" y="8001000"/>
             <a:ext cx="6903720" cy="320040"/>
           </a:xfrm>
           <a:prstGeom prst="rect">
@@ -11418,7 +11502,7 @@
         </p:nvSpPr>
         <p:spPr>
           <a:xfrm>
-            <a:off x="9966960" y="7966710"/>
+            <a:off x="9966960" y="8321040"/>
             <a:ext cx="6903720" cy="1291590"/>
           </a:xfrm>
           <a:prstGeom prst="rect">
@@ -11439,7 +11523,7 @@
                 </a:solidFill>
                 <a:latin typeface="Courier New"/>
               </a:rPr>
-              <a:t>I started with $100</a:t>
+              <a:t>Revenue now: 1250</a:t>
             </a:r>
           </a:p>
           <a:p>
@@ -11450,7 +11534,7 @@
                 </a:solidFill>
                 <a:latin typeface="Courier New"/>
               </a:rPr>
-              <a:t>Now I have $195</a:t>
+              <a:t>In 5 years: 1837</a:t>
             </a:r>
           </a:p>
           <a:p>
@@ -11461,7 +11545,7 @@
                 </a:solidFill>
                 <a:latin typeface="Courier New"/>
               </a:rPr>
-              <a:t>6.2831852</a:t>
+              <a:t>41</a:t>
             </a:r>
           </a:p>
         </p:txBody>
@@ -11743,7 +11827,7 @@
                 </a:solidFill>
                 <a:latin typeface="Courier New"/>
               </a:rPr>
-              <a:t>savings = 100</a:t>
+              <a:t>revenue = 1250</a:t>
             </a:r>
           </a:p>
           <a:p>
@@ -11754,7 +11838,7 @@
                 </a:solidFill>
                 <a:latin typeface="Courier New"/>
               </a:rPr>
-              <a:t>result = savings * 1.1 ** 7</a:t>
+              <a:t>result = revenue * 1.08 ** 5</a:t>
             </a:r>
           </a:p>
           <a:p>
@@ -11809,7 +11893,7 @@
                 </a:solidFill>
                 <a:latin typeface="Courier New"/>
               </a:rPr>
-              <a:t>print("Now I have $" + str(round(result, 2)))</a:t>
+              <a:t>print("In 5 years: " + str(round(result, 2)))</a:t>
             </a:r>
           </a:p>
           <a:p>
@@ -11842,7 +11926,7 @@
                 </a:solidFill>
                 <a:latin typeface="Courier New"/>
               </a:rPr>
-              <a:t>print(f"Now I have ${result:.2f}")</a:t>
+              <a:t>print(f"In 5 years: {result:.2f}")</a:t>
             </a:r>
           </a:p>
           <a:p>
@@ -11990,7 +12074,7 @@
                 </a:solidFill>
                 <a:latin typeface="Courier New"/>
               </a:rPr>
-              <a:t>Now I have $194.87</a:t>
+              <a:t>In 5 years: 1836.66</a:t>
             </a:r>
           </a:p>
           <a:p>
@@ -12001,7 +12085,7 @@
                 </a:solidFill>
                 <a:latin typeface="Courier New"/>
               </a:rPr>
-              <a:t>Now I have $194.87</a:t>
+              <a:t>In 5 years: 1836.66</a:t>
             </a:r>
           </a:p>
           <a:p>
@@ -12945,7 +13029,7 @@
             <a:pPr lvl="1"/>
             <a:r>
               <a:rPr sz="1900"/>
-              <a:t>Για 5 δωμάτια θέλουμε 5 μεταβλητές, για 100 μετρήσεις 100 μεταβλητές…</a:t>
+              <a:t>Για 5 μήνες θέλουμε 5 μεταβλητές, για 1000 παραγγελίες 1000 μεταβλητές…</a:t>
             </a:r>
           </a:p>
           <a:p>
@@ -13119,7 +13203,7 @@
                 </a:solidFill>
                 <a:latin typeface="Courier New"/>
               </a:rPr>
-              <a:t># Εμβαδά δωματίων (σε τ.μ.)</a:t>
+              <a:t># Μηνιαίες πωλήσεις (σε ευρώ)</a:t>
             </a:r>
           </a:p>
           <a:p>
@@ -13130,7 +13214,7 @@
                 </a:solidFill>
                 <a:latin typeface="Courier New"/>
               </a:rPr>
-              <a:t>hall = 11.25</a:t>
+              <a:t>jan = 1200</a:t>
             </a:r>
           </a:p>
           <a:p>
@@ -13141,7 +13225,7 @@
                 </a:solidFill>
                 <a:latin typeface="Courier New"/>
               </a:rPr>
-              <a:t>kit = 18.0</a:t>
+              <a:t>feb = 1550</a:t>
             </a:r>
           </a:p>
           <a:p>
@@ -13152,7 +13236,7 @@
                 </a:solidFill>
                 <a:latin typeface="Courier New"/>
               </a:rPr>
-              <a:t>liv = 20.0</a:t>
+              <a:t>mar = 1000</a:t>
             </a:r>
           </a:p>
           <a:p>
@@ -13163,7 +13247,7 @@
                 </a:solidFill>
                 <a:latin typeface="Courier New"/>
               </a:rPr>
-              <a:t>bed = 10.75</a:t>
+              <a:t>apr = 1800</a:t>
             </a:r>
           </a:p>
           <a:p>
@@ -13174,7 +13258,7 @@
                 </a:solidFill>
                 <a:latin typeface="Courier New"/>
               </a:rPr>
-              <a:t>bath = 9.50</a:t>
+              <a:t>may = 1650</a:t>
             </a:r>
           </a:p>
           <a:p>
@@ -13207,7 +13291,7 @@
                 </a:solidFill>
                 <a:latin typeface="Courier New"/>
               </a:rPr>
-              <a:t>areas = [hall, kit, liv, bed, bath]</a:t>
+              <a:t>sales = [jan, feb, mar, apr, may]</a:t>
             </a:r>
           </a:p>
           <a:p>
@@ -13218,7 +13302,7 @@
                 </a:solidFill>
                 <a:latin typeface="Courier New"/>
               </a:rPr>
-              <a:t>print(areas)</a:t>
+              <a:t>print(sales)</a:t>
             </a:r>
           </a:p>
         </p:txBody>
@@ -13344,7 +13428,7 @@
                 </a:solidFill>
                 <a:latin typeface="Courier New"/>
               </a:rPr>
-              <a:t>[11.25, 18.0, 20.0, 10.75, 9.5]</a:t>
+              <a:t>[1200, 1550, 1000, 1800, 1650]</a:t>
             </a:r>
           </a:p>
         </p:txBody>
@@ -13458,7 +13542,7 @@
                 </a:solidFill>
                 <a:latin typeface="Courier New"/>
               </a:rPr>
-              <a:t>type(areas)</a:t>
+              <a:t>type(products)</a:t>
             </a:r>
             <a:r>
               <a:rPr sz="1900"/>
@@ -13586,7 +13670,7 @@
                 </a:solidFill>
                 <a:latin typeface="Courier New"/>
               </a:rPr>
-              <a:t># Όνομα και εμβαδό εναλλάξ</a:t>
+              <a:t># Προϊόν και τιμή εναλλάξ</a:t>
             </a:r>
           </a:p>
           <a:p>
@@ -13597,7 +13681,7 @@
                 </a:solidFill>
                 <a:latin typeface="Courier New"/>
               </a:rPr>
-              <a:t>areas = ["hallway", 11.25,</a:t>
+              <a:t>products = ["laptop", 899.0,</a:t>
             </a:r>
           </a:p>
           <a:p>
@@ -13608,7 +13692,7 @@
                 </a:solidFill>
                 <a:latin typeface="Courier New"/>
               </a:rPr>
-              <a:t>         "kitchen", 18.0,</a:t>
+              <a:t>            "mouse", 19.9,</a:t>
             </a:r>
           </a:p>
           <a:p>
@@ -13619,7 +13703,7 @@
                 </a:solidFill>
                 <a:latin typeface="Courier New"/>
               </a:rPr>
-              <a:t>         "living room", 20.0,</a:t>
+              <a:t>            "monitor", 249.0,</a:t>
             </a:r>
           </a:p>
           <a:p>
@@ -13630,7 +13714,7 @@
                 </a:solidFill>
                 <a:latin typeface="Courier New"/>
               </a:rPr>
-              <a:t>         "bedroom", 10.75,</a:t>
+              <a:t>            "keyboard", 45.0,</a:t>
             </a:r>
           </a:p>
           <a:p>
@@ -13641,7 +13725,7 @@
                 </a:solidFill>
                 <a:latin typeface="Courier New"/>
               </a:rPr>
-              <a:t>         "bathroom", 9.50]</a:t>
+              <a:t>            "webcam", 59.0]</a:t>
             </a:r>
           </a:p>
           <a:p>
@@ -13663,7 +13747,7 @@
                 </a:solidFill>
                 <a:latin typeface="Courier New"/>
               </a:rPr>
-              <a:t>print(type(areas))</a:t>
+              <a:t>print(type(products))</a:t>
             </a:r>
           </a:p>
         </p:txBody>
@@ -13873,7 +13957,7 @@
             <a:pPr lvl="1"/>
             <a:r>
               <a:rPr sz="1900"/>
-              <a:t>Εδώ: [όνομα δωματίου, εμβαδό]</a:t>
+              <a:t>Εδώ: [προϊόν, τιμή]</a:t>
             </a:r>
           </a:p>
           <a:p>
@@ -14022,7 +14106,7 @@
                 </a:solidFill>
                 <a:latin typeface="Courier New"/>
               </a:rPr>
-              <a:t>house = [["hallway", 11.25],</a:t>
+              <a:t>catalog = [["laptop", 899.0],</a:t>
             </a:r>
           </a:p>
           <a:p>
@@ -14033,7 +14117,7 @@
                 </a:solidFill>
                 <a:latin typeface="Courier New"/>
               </a:rPr>
-              <a:t>         ["kitchen", 18.0],</a:t>
+              <a:t>           ["mouse", 19.9],</a:t>
             </a:r>
           </a:p>
           <a:p>
@@ -14044,7 +14128,7 @@
                 </a:solidFill>
                 <a:latin typeface="Courier New"/>
               </a:rPr>
-              <a:t>         ["living room", 20.0],</a:t>
+              <a:t>           ["monitor", 249.0],</a:t>
             </a:r>
           </a:p>
           <a:p>
@@ -14055,7 +14139,7 @@
                 </a:solidFill>
                 <a:latin typeface="Courier New"/>
               </a:rPr>
-              <a:t>         ["bedroom", 10.75],</a:t>
+              <a:t>           ["keyboard", 45.0],</a:t>
             </a:r>
           </a:p>
           <a:p>
@@ -14066,7 +14150,7 @@
                 </a:solidFill>
                 <a:latin typeface="Courier New"/>
               </a:rPr>
-              <a:t>         ["bathroom", 9.50]]</a:t>
+              <a:t>           ["webcam", 59.0]]</a:t>
             </a:r>
           </a:p>
           <a:p>
@@ -14088,7 +14172,7 @@
                 </a:solidFill>
                 <a:latin typeface="Courier New"/>
               </a:rPr>
-              <a:t>print(house[0])</a:t>
+              <a:t>print(catalog[0])</a:t>
             </a:r>
           </a:p>
         </p:txBody>
@@ -14214,7 +14298,7 @@
                 </a:solidFill>
                 <a:latin typeface="Courier New"/>
               </a:rPr>
-              <a:t>['hallway', 11.25]</a:t>
+              <a:t>['laptop', 899.0]</a:t>
             </a:r>
           </a:p>
         </p:txBody>
@@ -14354,7 +14438,7 @@
             <a:pPr lvl="1"/>
             <a:r>
               <a:rPr sz="1800"/>
-              <a:t>Αν η λίστα έχει μείγμα ονομάτων και αριθμών, το sum() δίνει TypeError</a:t>
+              <a:t>Αν η λίστα έχει μείγμα προϊόντων και τιμών, το sum() δίνει TypeError</a:t>
             </a:r>
           </a:p>
         </p:txBody>
@@ -14478,7 +14562,7 @@
                 </a:solidFill>
                 <a:latin typeface="Courier New"/>
               </a:rPr>
-              <a:t>areas = [11.25, 18.0, 20.0, 10.75, 9.50]</a:t>
+              <a:t>sales = [1200, 1550, 1000, 1800, 1650]</a:t>
             </a:r>
           </a:p>
           <a:p>
@@ -14500,7 +14584,7 @@
                 </a:solidFill>
                 <a:latin typeface="Courier New"/>
               </a:rPr>
-              <a:t>print(len(areas))</a:t>
+              <a:t>print(len(sales))</a:t>
             </a:r>
           </a:p>
           <a:p>
@@ -14511,7 +14595,7 @@
                 </a:solidFill>
                 <a:latin typeface="Courier New"/>
               </a:rPr>
-              <a:t>print(20.0 in areas)</a:t>
+              <a:t>print(1800 in sales)</a:t>
             </a:r>
           </a:p>
           <a:p>
@@ -14522,7 +14606,7 @@
                 </a:solidFill>
                 <a:latin typeface="Courier New"/>
               </a:rPr>
-              <a:t>print(25.0 in areas)</a:t>
+              <a:t>print(2000 in sales)</a:t>
             </a:r>
           </a:p>
           <a:p>
@@ -14533,7 +14617,7 @@
                 </a:solidFill>
                 <a:latin typeface="Courier New"/>
               </a:rPr>
-              <a:t>print(sum(areas))</a:t>
+              <a:t>print(sum(sales))</a:t>
             </a:r>
           </a:p>
           <a:p>
@@ -14544,7 +14628,7 @@
                 </a:solidFill>
                 <a:latin typeface="Courier New"/>
               </a:rPr>
-              <a:t>print(max(areas), min(areas))</a:t>
+              <a:t>print(max(sales), min(sales))</a:t>
             </a:r>
           </a:p>
           <a:p>
@@ -14555,7 +14639,7 @@
                 </a:solidFill>
                 <a:latin typeface="Courier New"/>
               </a:rPr>
-              <a:t>print(sum(areas) / len(areas))</a:t>
+              <a:t>print(sum(sales) / len(sales))</a:t>
             </a:r>
           </a:p>
         </p:txBody>
@@ -14714,7 +14798,7 @@
                 </a:solidFill>
                 <a:latin typeface="Courier New"/>
               </a:rPr>
-              <a:t>69.5</a:t>
+              <a:t>7200</a:t>
             </a:r>
           </a:p>
           <a:p>
@@ -14725,7 +14809,7 @@
                 </a:solidFill>
                 <a:latin typeface="Courier New"/>
               </a:rPr>
-              <a:t>20.0 9.5</a:t>
+              <a:t>1800 1000</a:t>
             </a:r>
           </a:p>
           <a:p>
@@ -14736,7 +14820,7 @@
                 </a:solidFill>
                 <a:latin typeface="Courier New"/>
               </a:rPr>
-              <a:t>13.9</a:t>
+              <a:t>1440.0</a:t>
             </a:r>
           </a:p>
         </p:txBody>
@@ -14810,7 +14894,7 @@
                 </a:solidFill>
                 <a:latin typeface="Courier New"/>
               </a:rPr>
-              <a:t>x = ["a", "b", "c", "d"]</a:t>
+              <a:t>q = ["Q1", "Q2", "Q3", "Q4"]   # τρίμηνα</a:t>
             </a:r>
           </a:p>
         </p:txBody>
@@ -14990,7 +15074,7 @@
                 </a:solidFill>
                 <a:latin typeface="Courier New"/>
               </a:rPr>
-              <a:t>"a"</a:t>
+              <a:t>"Q1"</a:t>
             </a:r>
           </a:p>
         </p:txBody>
@@ -15157,7 +15241,7 @@
                 </a:solidFill>
                 <a:latin typeface="Courier New"/>
               </a:rPr>
-              <a:t>"b"</a:t>
+              <a:t>"Q2"</a:t>
             </a:r>
           </a:p>
         </p:txBody>
@@ -15324,7 +15408,7 @@
                 </a:solidFill>
                 <a:latin typeface="Courier New"/>
               </a:rPr>
-              <a:t>"c"</a:t>
+              <a:t>"Q3"</a:t>
             </a:r>
           </a:p>
         </p:txBody>
@@ -15491,7 +15575,7 @@
                 </a:solidFill>
                 <a:latin typeface="Courier New"/>
               </a:rPr>
-              <a:t>"d"</a:t>
+              <a:t>"Q4"</a:t>
             </a:r>
           </a:p>
         </p:txBody>
@@ -15638,7 +15722,7 @@
                 </a:solidFill>
                 <a:latin typeface="Courier New"/>
               </a:rPr>
-              <a:t>IPython Shell</a:t>
+              <a:t>Console</a:t>
             </a:r>
           </a:p>
         </p:txBody>
@@ -15672,7 +15756,7 @@
                 </a:solidFill>
                 <a:latin typeface="Courier New"/>
               </a:rPr>
-              <a:t>x[0]   </a:t>
+              <a:t>q[0]   </a:t>
             </a:r>
             <a:r>
               <a:rPr sz="1800">
@@ -15692,7 +15776,7 @@
                 </a:solidFill>
                 <a:latin typeface="Courier New"/>
               </a:rPr>
-              <a:t>x[1]   </a:t>
+              <a:t>q[1]   </a:t>
             </a:r>
             <a:r>
               <a:rPr sz="1800">
@@ -15712,7 +15796,7 @@
                 </a:solidFill>
                 <a:latin typeface="Courier New"/>
               </a:rPr>
-              <a:t>x[-1]  </a:t>
+              <a:t>q[-1]  </a:t>
             </a:r>
             <a:r>
               <a:rPr sz="1800">
@@ -15732,7 +15816,7 @@
                 </a:solidFill>
                 <a:latin typeface="Courier New"/>
               </a:rPr>
-              <a:t>x[-3]  </a:t>
+              <a:t>q[-3]  </a:t>
             </a:r>
             <a:r>
               <a:rPr sz="1800">
@@ -15741,7 +15825,7 @@
                 </a:solidFill>
                 <a:latin typeface="Courier New"/>
               </a:rPr>
-              <a:t># το ίδιο με x[1]</a:t>
+              <a:t># το ίδιο με q[1]</a:t>
             </a:r>
           </a:p>
         </p:txBody>
@@ -15865,7 +15949,7 @@
                 </a:solidFill>
                 <a:latin typeface="Courier New"/>
               </a:rPr>
-              <a:t>'a'</a:t>
+              <a:t>'Q1'</a:t>
             </a:r>
           </a:p>
           <a:p>
@@ -15876,7 +15960,7 @@
                 </a:solidFill>
                 <a:latin typeface="Courier New"/>
               </a:rPr>
-              <a:t>'b'</a:t>
+              <a:t>'Q2'</a:t>
             </a:r>
           </a:p>
           <a:p>
@@ -15887,7 +15971,7 @@
                 </a:solidFill>
                 <a:latin typeface="Courier New"/>
               </a:rPr>
-              <a:t>'d'</a:t>
+              <a:t>'Q4'</a:t>
             </a:r>
           </a:p>
           <a:p>
@@ -15898,7 +15982,7 @@
                 </a:solidFill>
                 <a:latin typeface="Courier New"/>
               </a:rPr>
-              <a:t>'b'</a:t>
+              <a:t>'Q2'</a:t>
             </a:r>
           </a:p>
         </p:txBody>
@@ -15985,7 +16069,7 @@
             <a:pPr lvl="1"/>
             <a:r>
               <a:rPr sz="1900"/>
-              <a:t>Μέτρα προσεκτικά: τα ονόματα και τα εμβαδά εναλλάσσονται</a:t>
+              <a:t>Μέτρα προσεκτικά: τα προϊόντα και οι τιμές εναλλάσσονται</a:t>
             </a:r>
           </a:p>
           <a:p>
@@ -16127,7 +16211,7 @@
                 </a:solidFill>
                 <a:latin typeface="Courier New"/>
               </a:rPr>
-              <a:t>areas = ["hallway", 11.25, "kitchen", 18.0,</a:t>
+              <a:t>products = ["laptop", 899.0, "mouse", 19.9,</a:t>
             </a:r>
           </a:p>
           <a:p>
@@ -16138,7 +16222,7 @@
                 </a:solidFill>
                 <a:latin typeface="Courier New"/>
               </a:rPr>
-              <a:t>         "living room", 20.0,</a:t>
+              <a:t>            "monitor", 249.0,</a:t>
             </a:r>
           </a:p>
           <a:p>
@@ -16149,7 +16233,7 @@
                 </a:solidFill>
                 <a:latin typeface="Courier New"/>
               </a:rPr>
-              <a:t>         "bedroom", 10.75, "bathroom", 9.50]</a:t>
+              <a:t>            "keyboard", 45.0, "webcam", 59.0]</a:t>
             </a:r>
           </a:p>
           <a:p>
@@ -16171,7 +16255,7 @@
                 </a:solidFill>
                 <a:latin typeface="Courier New"/>
               </a:rPr>
-              <a:t>print(areas[1])    </a:t>
+              <a:t>print(products[1])    </a:t>
             </a:r>
             <a:r>
               <a:rPr sz="1800">
@@ -16191,7 +16275,7 @@
                 </a:solidFill>
                 <a:latin typeface="Courier New"/>
               </a:rPr>
-              <a:t>print(areas[-1])   </a:t>
+              <a:t>print(products[-1])   </a:t>
             </a:r>
             <a:r>
               <a:rPr sz="1800">
@@ -16211,7 +16295,7 @@
                 </a:solidFill>
                 <a:latin typeface="Courier New"/>
               </a:rPr>
-              <a:t>print(areas[5])    </a:t>
+              <a:t>print(products[5])    </a:t>
             </a:r>
             <a:r>
               <a:rPr sz="1800">
@@ -16345,7 +16429,7 @@
                 </a:solidFill>
                 <a:latin typeface="Courier New"/>
               </a:rPr>
-              <a:t>areas[1]  → 11.25   το δεύτερο στοιχείο</a:t>
+              <a:t>products[1]  → 899.0   το δεύτερο στοιχείο</a:t>
             </a:r>
           </a:p>
           <a:p>
@@ -16357,7 +16441,7 @@
                 </a:solidFill>
                 <a:latin typeface="Courier New"/>
               </a:rPr>
-              <a:t>areas[-1] → 9.5     το τελευταίο</a:t>
+              <a:t>products[-1] → 59.0    το τελευταίο</a:t>
             </a:r>
           </a:p>
           <a:p>
@@ -16369,7 +16453,7 @@
                 </a:solidFill>
                 <a:latin typeface="Courier New"/>
               </a:rPr>
-              <a:t>areas[5]  → 20.0    το έκτο (living room)</a:t>
+              <a:t>products[5]  → 249.0   το έκτο (monitor)</a:t>
             </a:r>
           </a:p>
         </p:txBody>
@@ -16590,7 +16674,7 @@
                 </a:solidFill>
                 <a:latin typeface="Courier New"/>
               </a:rPr>
-              <a:t>x = ["a", "b", "c", "d"]        x[1:3]</a:t>
+              <a:t>q = ["Q1", "Q2", "Q3", "Q4"]        q[1:3]</a:t>
             </a:r>
           </a:p>
         </p:txBody>
@@ -16700,7 +16784,7 @@
                 </a:solidFill>
                 <a:latin typeface="Courier New"/>
               </a:rPr>
-              <a:t>"a"</a:t>
+              <a:t>"Q1"</a:t>
             </a:r>
           </a:p>
         </p:txBody>
@@ -16810,7 +16894,7 @@
                 </a:solidFill>
                 <a:latin typeface="Courier New"/>
               </a:rPr>
-              <a:t>"b"</a:t>
+              <a:t>"Q2"</a:t>
             </a:r>
           </a:p>
         </p:txBody>
@@ -16920,7 +17004,7 @@
                 </a:solidFill>
                 <a:latin typeface="Courier New"/>
               </a:rPr>
-              <a:t>"c"</a:t>
+              <a:t>"Q3"</a:t>
             </a:r>
           </a:p>
         </p:txBody>
@@ -17030,7 +17114,7 @@
                 </a:solidFill>
                 <a:latin typeface="Courier New"/>
               </a:rPr>
-              <a:t>"d"</a:t>
+              <a:t>"Q4"</a:t>
             </a:r>
           </a:p>
         </p:txBody>
@@ -17155,7 +17239,7 @@
                 </a:solidFill>
                 <a:latin typeface="Courier New"/>
               </a:rPr>
-              <a:t>IPython Shell</a:t>
+              <a:t>Console</a:t>
             </a:r>
           </a:p>
         </p:txBody>
@@ -17189,7 +17273,7 @@
                 </a:solidFill>
                 <a:latin typeface="Courier New"/>
               </a:rPr>
-              <a:t>x[1:3]</a:t>
+              <a:t>q[1:3]</a:t>
             </a:r>
           </a:p>
           <a:p>
@@ -17200,7 +17284,7 @@
                 </a:solidFill>
                 <a:latin typeface="Courier New"/>
               </a:rPr>
-              <a:t>x[0:2]</a:t>
+              <a:t>q[0:2]</a:t>
             </a:r>
           </a:p>
         </p:txBody>
@@ -17324,7 +17408,7 @@
                 </a:solidFill>
                 <a:latin typeface="Courier New"/>
               </a:rPr>
-              <a:t>['b', 'c']</a:t>
+              <a:t>['Q2', 'Q3']</a:t>
             </a:r>
           </a:p>
           <a:p>
@@ -17335,7 +17419,7 @@
                 </a:solidFill>
                 <a:latin typeface="Courier New"/>
               </a:rPr>
-              <a:t>['a', 'b']</a:t>
+              <a:t>['Q1', 'Q2']</a:t>
             </a:r>
           </a:p>
         </p:txBody>
@@ -17402,11 +17486,11 @@
                 </a:solidFill>
                 <a:latin typeface="Courier New"/>
               </a:rPr>
-              <a:t>x[:2]</a:t>
+              <a:t>q[:2]</a:t>
             </a:r>
             <a:r>
               <a:rPr sz="2200"/>
-              <a:t>   από την αρχή μέχρι τον δείκτη 2 (όχι μαζί)</a:t>
+              <a:t>   από την αρχή μέχρι τον δείκτη 2 (όχι μαζί): το πρώτο εξάμηνο</a:t>
             </a:r>
           </a:p>
           <a:p>
@@ -17418,11 +17502,11 @@
                 </a:solidFill>
                 <a:latin typeface="Courier New"/>
               </a:rPr>
-              <a:t>x[2:]</a:t>
+              <a:t>q[2:]</a:t>
             </a:r>
             <a:r>
               <a:rPr sz="2200"/>
-              <a:t>   από τον δείκτη 2 μέχρι το τέλος</a:t>
+              <a:t>   από τον δείκτη 2 μέχρι το τέλος: το δεύτερο εξάμηνο</a:t>
             </a:r>
           </a:p>
           <a:p>
@@ -17434,7 +17518,7 @@
                 </a:solidFill>
                 <a:latin typeface="Courier New"/>
               </a:rPr>
-              <a:t>x[:]</a:t>
+              <a:t>q[:]</a:t>
             </a:r>
             <a:r>
               <a:rPr sz="2200"/>
@@ -17594,7 +17678,7 @@
                 </a:solidFill>
                 <a:latin typeface="Courier New"/>
               </a:rPr>
-              <a:t>x = ["a", "b", "c", "d"]</a:t>
+              <a:t>q = ["Q1", "Q2", "Q3", "Q4"]</a:t>
             </a:r>
           </a:p>
           <a:p>
@@ -17616,7 +17700,7 @@
                 </a:solidFill>
                 <a:latin typeface="Courier New"/>
               </a:rPr>
-              <a:t>print(x[:2])</a:t>
+              <a:t>print(q[:2])</a:t>
             </a:r>
           </a:p>
           <a:p>
@@ -17627,7 +17711,7 @@
                 </a:solidFill>
                 <a:latin typeface="Courier New"/>
               </a:rPr>
-              <a:t>print(x[2:])</a:t>
+              <a:t>print(q[2:])</a:t>
             </a:r>
           </a:p>
           <a:p>
@@ -17638,7 +17722,7 @@
                 </a:solidFill>
                 <a:latin typeface="Courier New"/>
               </a:rPr>
-              <a:t>print(x[:])</a:t>
+              <a:t>print(q[:])</a:t>
             </a:r>
           </a:p>
           <a:p>
@@ -17649,7 +17733,7 @@
                 </a:solidFill>
                 <a:latin typeface="Courier New"/>
               </a:rPr>
-              <a:t>print(x[-2:])</a:t>
+              <a:t>print(q[-2:])</a:t>
             </a:r>
           </a:p>
         </p:txBody>
@@ -17775,7 +17859,7 @@
                 </a:solidFill>
                 <a:latin typeface="Courier New"/>
               </a:rPr>
-              <a:t>['a', 'b']</a:t>
+              <a:t>['Q1', 'Q2']</a:t>
             </a:r>
           </a:p>
           <a:p>
@@ -17786,7 +17870,7 @@
                 </a:solidFill>
                 <a:latin typeface="Courier New"/>
               </a:rPr>
-              <a:t>['c', 'd']</a:t>
+              <a:t>['Q3', 'Q4']</a:t>
             </a:r>
           </a:p>
           <a:p>
@@ -17797,7 +17881,7 @@
                 </a:solidFill>
                 <a:latin typeface="Courier New"/>
               </a:rPr>
-              <a:t>['a', 'b', 'c', 'd']</a:t>
+              <a:t>['Q1', 'Q2', 'Q3', 'Q4']</a:t>
             </a:r>
           </a:p>
           <a:p>
@@ -17808,7 +17892,7 @@
                 </a:solidFill>
                 <a:latin typeface="Courier New"/>
               </a:rPr>
-              <a:t>['c', 'd']</a:t>
+              <a:t>['Q3', 'Q4']</a:t>
             </a:r>
           </a:p>
         </p:txBody>
@@ -17847,7 +17931,7 @@
           <a:lstStyle/>
           <a:p>
             <a:r>
-              <a:t>Άσκηση: κάτω και πάνω όροφος</a:t>
+              <a:t>Άσκηση: πρώτο και δεύτερο εξάμηνο</a:t>
             </a:r>
           </a:p>
         </p:txBody>
@@ -17881,21 +17965,21 @@
             <a:pPr lvl="1"/>
             <a:r>
               <a:rPr sz="1800"/>
-              <a:t>downstairs: τα 6 πρώτα στοιχεία της areas</a:t>
+              <a:t>h1: οι πωλήσεις των 6 πρώτων μηνών</a:t>
             </a:r>
           </a:p>
           <a:p>
             <a:pPr lvl="1"/>
             <a:r>
               <a:rPr sz="1800"/>
-              <a:t>upstairs: τα 4 τελευταία</a:t>
+              <a:t>h2: οι πωλήσεις των 6 τελευταίων</a:t>
             </a:r>
           </a:p>
           <a:p>
             <a:pPr lvl="1"/>
             <a:r>
               <a:rPr sz="1800"/>
-              <a:t>Τύπωσε και τις δύο λίστες</a:t>
+              <a:t>Τύπωσε και τις δύο λίστες και το σύνολο κάθε εξαμήνου</a:t>
             </a:r>
           </a:p>
           <a:p>
@@ -17918,7 +18002,7 @@
                 </a:solidFill>
                 <a:latin typeface="Courier New"/>
               </a:rPr>
-              <a:t>areas[0:6]</a:t>
+              <a:t>sales[0:6]</a:t>
             </a:r>
             <a:r>
               <a:rPr sz="1800"/>
@@ -17931,7 +18015,7 @@
                 </a:solidFill>
                 <a:latin typeface="Courier New"/>
               </a:rPr>
-              <a:t>areas[:6]</a:t>
+              <a:t>sales[:6]</a:t>
             </a:r>
           </a:p>
           <a:p>
@@ -17943,7 +18027,7 @@
                 </a:solidFill>
                 <a:latin typeface="Courier New"/>
               </a:rPr>
-              <a:t>areas[6:10]</a:t>
+              <a:t>sales[6:12]</a:t>
             </a:r>
             <a:r>
               <a:rPr sz="1800"/>
@@ -17956,7 +18040,7 @@
                 </a:solidFill>
                 <a:latin typeface="Courier New"/>
               </a:rPr>
-              <a:t>areas[6:]</a:t>
+              <a:t>sales[6:]</a:t>
             </a:r>
           </a:p>
         </p:txBody>
@@ -18080,7 +18164,7 @@
                 </a:solidFill>
                 <a:latin typeface="Courier New"/>
               </a:rPr>
-              <a:t>areas = ["hallway", 11.25, "kitchen", 18.0,</a:t>
+              <a:t>sales = [1200, 1550, 1000, 1800, 1650, 1400,</a:t>
             </a:r>
           </a:p>
           <a:p>
@@ -18091,7 +18175,7 @@
                 </a:solidFill>
                 <a:latin typeface="Courier New"/>
               </a:rPr>
-              <a:t>         "living room", 20.0, "bedroom", 10.75,</a:t>
+              <a:t>         1900, 2100, 1700, 1600, 2300, 2800]</a:t>
             </a:r>
           </a:p>
           <a:p>
@@ -18102,7 +18186,7 @@
                 </a:solidFill>
                 <a:latin typeface="Courier New"/>
               </a:rPr>
-              <a:t>         "bathroom", 9.50]</a:t>
+              <a:t> </a:t>
             </a:r>
           </a:p>
           <a:p>
@@ -18113,6 +18197,28 @@
                 </a:solidFill>
                 <a:latin typeface="Courier New"/>
               </a:rPr>
+              <a:t>h1 = sales[:6]</a:t>
+            </a:r>
+          </a:p>
+          <a:p>
+            <a:r>
+              <a:rPr sz="1680">
+                <a:solidFill>
+                  <a:srgbClr val="F4F6FF"/>
+                </a:solidFill>
+                <a:latin typeface="Courier New"/>
+              </a:rPr>
+              <a:t>h2 = sales[6:]</a:t>
+            </a:r>
+          </a:p>
+          <a:p>
+            <a:r>
+              <a:rPr sz="1680">
+                <a:solidFill>
+                  <a:srgbClr val="F4F6FF"/>
+                </a:solidFill>
+                <a:latin typeface="Courier New"/>
+              </a:rPr>
               <a:t> </a:t>
             </a:r>
           </a:p>
@@ -18124,7 +18230,7 @@
                 </a:solidFill>
                 <a:latin typeface="Courier New"/>
               </a:rPr>
-              <a:t>downstairs = areas[:6]</a:t>
+              <a:t>print(h1)</a:t>
             </a:r>
           </a:p>
           <a:p>
@@ -18135,7 +18241,7 @@
                 </a:solidFill>
                 <a:latin typeface="Courier New"/>
               </a:rPr>
-              <a:t>upstairs = areas[6:]</a:t>
+              <a:t>print(h2)</a:t>
             </a:r>
           </a:p>
           <a:p>
@@ -18146,29 +18252,7 @@
                 </a:solidFill>
                 <a:latin typeface="Courier New"/>
               </a:rPr>
-              <a:t> </a:t>
-            </a:r>
-          </a:p>
-          <a:p>
-            <a:r>
-              <a:rPr sz="1680">
-                <a:solidFill>
-                  <a:srgbClr val="F4F6FF"/>
-                </a:solidFill>
-                <a:latin typeface="Courier New"/>
-              </a:rPr>
-              <a:t>print(downstairs)</a:t>
-            </a:r>
-          </a:p>
-          <a:p>
-            <a:r>
-              <a:rPr sz="1680">
-                <a:solidFill>
-                  <a:srgbClr val="F4F6FF"/>
-                </a:solidFill>
-                <a:latin typeface="Courier New"/>
-              </a:rPr>
-              <a:t>print(upstairs)</a:t>
+              <a:t>print(sum(h1), sum(h2))</a:t>
             </a:r>
           </a:p>
         </p:txBody>
@@ -18182,7 +18266,7 @@
         <p:spPr>
           <a:xfrm>
             <a:off x="9692640" y="6633972"/>
-            <a:ext cx="7452360" cy="1347216"/>
+            <a:ext cx="7452360" cy="1677924"/>
           </a:xfrm>
           <a:prstGeom prst="roundRect">
             <a:avLst>
@@ -18274,7 +18358,7 @@
         <p:spPr>
           <a:xfrm>
             <a:off x="9966960" y="7045452"/>
-            <a:ext cx="6903720" cy="890016"/>
+            <a:ext cx="6903720" cy="1220724"/>
           </a:xfrm>
           <a:prstGeom prst="rect">
             <a:avLst/>
@@ -18294,7 +18378,7 @@
                 </a:solidFill>
                 <a:latin typeface="Courier New"/>
               </a:rPr>
-              <a:t>['hallway', 11.25, 'kitchen', 18.0, 'living room', 20.0]</a:t>
+              <a:t>[1200, 1550, 1000, 1800, 1650, 1400]</a:t>
             </a:r>
           </a:p>
           <a:p>
@@ -18305,7 +18389,18 @@
                 </a:solidFill>
                 <a:latin typeface="Courier New"/>
               </a:rPr>
-              <a:t>['bedroom', 10.75, 'bathroom', 9.5]</a:t>
+              <a:t>[1900, 2100, 1700, 1600, 2300, 2800]</a:t>
+            </a:r>
+          </a:p>
+          <a:p>
+            <a:r>
+              <a:rPr sz="1680">
+                <a:solidFill>
+                  <a:srgbClr val="1B2F6B"/>
+                </a:solidFill>
+                <a:latin typeface="Courier New"/>
+              </a:rPr>
+              <a:t>8600 12400</a:t>
             </a:r>
           </a:p>
         </p:txBody>
@@ -18498,11 +18593,11 @@
                 </a:solidFill>
                 <a:latin typeface="Courier New"/>
               </a:rPr>
-              <a:t>x[2]</a:t>
+              <a:t>sales[2]</a:t>
             </a:r>
             <a:r>
               <a:rPr sz="1900"/>
-              <a:t>  →  η τρίτη εσωτερική λίστα</a:t>
+              <a:t>  →  η τρίτη εσωτερική λίστα (Q3)</a:t>
             </a:r>
           </a:p>
           <a:p>
@@ -18514,11 +18609,11 @@
                 </a:solidFill>
                 <a:latin typeface="Courier New"/>
               </a:rPr>
-              <a:t>x[2][0]</a:t>
+              <a:t>sales[2][0]</a:t>
             </a:r>
             <a:r>
               <a:rPr sz="1900"/>
-              <a:t>  →  το πρώτο στοιχείο της</a:t>
+              <a:t>  →  το πρώτο στοιχείο της (ο πρώτος μήνας του Q3)</a:t>
             </a:r>
           </a:p>
           <a:p>
@@ -18530,7 +18625,7 @@
                 </a:solidFill>
                 <a:latin typeface="Courier New"/>
               </a:rPr>
-              <a:t>x[2][:2]</a:t>
+              <a:t>sales[2][:2]</a:t>
             </a:r>
             <a:r>
               <a:rPr sz="1900"/>
@@ -18566,7 +18661,7 @@
         <p:spPr>
           <a:xfrm>
             <a:off x="9692640" y="2743200"/>
-            <a:ext cx="7452360" cy="3422904"/>
+            <a:ext cx="7452360" cy="3800855"/>
           </a:xfrm>
           <a:prstGeom prst="roundRect">
             <a:avLst>
@@ -18656,7 +18751,7 @@
         <p:spPr>
           <a:xfrm>
             <a:off x="9966960" y="3200400"/>
-            <a:ext cx="6903720" cy="2874264"/>
+            <a:ext cx="6903720" cy="3252215"/>
           </a:xfrm>
           <a:prstGeom prst="rect">
             <a:avLst/>
@@ -18672,11 +18767,22 @@
             <a:r>
               <a:rPr sz="1920">
                 <a:solidFill>
+                  <a:srgbClr val="9FB3E8"/>
+                </a:solidFill>
+                <a:latin typeface="Courier New"/>
+              </a:rPr>
+              <a:t># Μία λίστα ανά τρίμηνο, τρεις μήνες η καθεμία</a:t>
+            </a:r>
+          </a:p>
+          <a:p>
+            <a:r>
+              <a:rPr sz="1920">
+                <a:solidFill>
                   <a:srgbClr val="F4F6FF"/>
                 </a:solidFill>
                 <a:latin typeface="Courier New"/>
               </a:rPr>
-              <a:t>x = [["a", "b", "c"],</a:t>
+              <a:t>sales = [[1200, 1550, 1000],</a:t>
             </a:r>
           </a:p>
           <a:p>
@@ -18687,7 +18793,7 @@
                 </a:solidFill>
                 <a:latin typeface="Courier New"/>
               </a:rPr>
-              <a:t>     ["d", "e", "f"],</a:t>
+              <a:t>         [1800, 1650, 1400],</a:t>
             </a:r>
           </a:p>
           <a:p>
@@ -18698,7 +18804,7 @@
                 </a:solidFill>
                 <a:latin typeface="Courier New"/>
               </a:rPr>
-              <a:t>     ["g", "h", "i"]]</a:t>
+              <a:t>         [1900, 2100, 1700]]</a:t>
             </a:r>
           </a:p>
           <a:p>
@@ -18720,7 +18826,7 @@
                 </a:solidFill>
                 <a:latin typeface="Courier New"/>
               </a:rPr>
-              <a:t>print(x[2])</a:t>
+              <a:t>print(sales[2])</a:t>
             </a:r>
           </a:p>
           <a:p>
@@ -18731,7 +18837,7 @@
                 </a:solidFill>
                 <a:latin typeface="Courier New"/>
               </a:rPr>
-              <a:t>print(x[2][0])</a:t>
+              <a:t>print(sales[2][0])</a:t>
             </a:r>
           </a:p>
           <a:p>
@@ -18742,7 +18848,7 @@
                 </a:solidFill>
                 <a:latin typeface="Courier New"/>
               </a:rPr>
-              <a:t>print(x[2][:2])</a:t>
+              <a:t>print(sales[2][:2])</a:t>
             </a:r>
           </a:p>
         </p:txBody>
@@ -18755,7 +18861,7 @@
         </p:nvSpPr>
         <p:spPr>
           <a:xfrm>
-            <a:off x="9692640" y="6303264"/>
+            <a:off x="9692640" y="6681216"/>
             <a:ext cx="7452360" cy="1819656"/>
           </a:xfrm>
           <a:prstGeom prst="roundRect">
@@ -18812,7 +18918,7 @@
         </p:nvSpPr>
         <p:spPr>
           <a:xfrm>
-            <a:off x="9966960" y="6394704"/>
+            <a:off x="9966960" y="6772656"/>
             <a:ext cx="6903720" cy="320040"/>
           </a:xfrm>
           <a:prstGeom prst="rect">
@@ -18847,7 +18953,7 @@
         </p:nvSpPr>
         <p:spPr>
           <a:xfrm>
-            <a:off x="9966960" y="6714744"/>
+            <a:off x="9966960" y="7092696"/>
             <a:ext cx="6903720" cy="1362456"/>
           </a:xfrm>
           <a:prstGeom prst="rect">
@@ -18868,7 +18974,7 @@
                 </a:solidFill>
                 <a:latin typeface="Courier New"/>
               </a:rPr>
-              <a:t>['g', 'h', 'i']</a:t>
+              <a:t>[1900, 2100, 1700]</a:t>
             </a:r>
           </a:p>
           <a:p>
@@ -18879,7 +18985,7 @@
                 </a:solidFill>
                 <a:latin typeface="Courier New"/>
               </a:rPr>
-              <a:t>g</a:t>
+              <a:t>1900</a:t>
             </a:r>
           </a:p>
           <a:p>
@@ -18890,7 +18996,7 @@
                 </a:solidFill>
                 <a:latin typeface="Courier New"/>
               </a:rPr>
-              <a:t>['g', 'h']</a:t>
+              <a:t>[1900, 2100]</a:t>
             </a:r>
           </a:p>
         </p:txBody>
@@ -18968,11 +19074,11 @@
                 </a:solidFill>
                 <a:latin typeface="Courier New"/>
               </a:rPr>
-              <a:t>x[1] = "r"</a:t>
+              <a:t>sales[1] = 1600</a:t>
             </a:r>
             <a:r>
               <a:rPr sz="1800"/>
-              <a:t>  αλλάζει το δεύτερο στοιχείο</a:t>
+              <a:t>  διορθώνει το δεύτερο στοιχείο</a:t>
             </a:r>
           </a:p>
           <a:p>
@@ -18995,7 +19101,7 @@
                 </a:solidFill>
                 <a:latin typeface="Courier New"/>
               </a:rPr>
-              <a:t>x[2:] = ["s", "t"]</a:t>
+              <a:t>sales[2:] = [1100, 1900]</a:t>
             </a:r>
             <a:r>
               <a:rPr sz="1800"/>
@@ -19031,7 +19137,7 @@
         <p:spPr>
           <a:xfrm>
             <a:off x="9692640" y="2743200"/>
-            <a:ext cx="7452360" cy="3422904"/>
+            <a:ext cx="7452360" cy="4178807"/>
           </a:xfrm>
           <a:prstGeom prst="roundRect">
             <a:avLst>
@@ -19121,7 +19227,7 @@
         <p:spPr>
           <a:xfrm>
             <a:off x="9966960" y="3200400"/>
-            <a:ext cx="6903720" cy="2874264"/>
+            <a:ext cx="6903720" cy="3630167"/>
           </a:xfrm>
           <a:prstGeom prst="rect">
             <a:avLst/>
@@ -19141,7 +19247,7 @@
                 </a:solidFill>
                 <a:latin typeface="Courier New"/>
               </a:rPr>
-              <a:t>x = ["a", "b", "c", "d"]</a:t>
+              <a:t>sales = [1200, 1550, 1000, 1800]</a:t>
             </a:r>
           </a:p>
           <a:p>
@@ -19159,11 +19265,22 @@
             <a:r>
               <a:rPr sz="1920">
                 <a:solidFill>
+                  <a:srgbClr val="9FB3E8"/>
+                </a:solidFill>
+                <a:latin typeface="Courier New"/>
+              </a:rPr>
+              <a:t># Διόρθωση του Φεβρουαρίου</a:t>
+            </a:r>
+          </a:p>
+          <a:p>
+            <a:r>
+              <a:rPr sz="1920">
+                <a:solidFill>
                   <a:srgbClr val="F4F6FF"/>
                 </a:solidFill>
                 <a:latin typeface="Courier New"/>
               </a:rPr>
-              <a:t>x[1] = "r"</a:t>
+              <a:t>sales[1] = 1600</a:t>
             </a:r>
           </a:p>
           <a:p>
@@ -19174,7 +19291,7 @@
                 </a:solidFill>
                 <a:latin typeface="Courier New"/>
               </a:rPr>
-              <a:t>print(x)</a:t>
+              <a:t>print(sales)</a:t>
             </a:r>
           </a:p>
           <a:p>
@@ -19192,11 +19309,22 @@
             <a:r>
               <a:rPr sz="1920">
                 <a:solidFill>
+                  <a:srgbClr val="9FB3E8"/>
+                </a:solidFill>
+                <a:latin typeface="Courier New"/>
+              </a:rPr>
+              <a:t># Διόρθωση Μαρτίου και Απριλίου μαζί</a:t>
+            </a:r>
+          </a:p>
+          <a:p>
+            <a:r>
+              <a:rPr sz="1920">
+                <a:solidFill>
                   <a:srgbClr val="F4F6FF"/>
                 </a:solidFill>
                 <a:latin typeface="Courier New"/>
               </a:rPr>
-              <a:t>x[2:] = ["s", "t"]</a:t>
+              <a:t>sales[2:] = [1100, 1900]</a:t>
             </a:r>
           </a:p>
           <a:p>
@@ -19207,7 +19335,7 @@
                 </a:solidFill>
                 <a:latin typeface="Courier New"/>
               </a:rPr>
-              <a:t>print(x)</a:t>
+              <a:t>print(sales)</a:t>
             </a:r>
           </a:p>
         </p:txBody>
@@ -19220,7 +19348,7 @@
         </p:nvSpPr>
         <p:spPr>
           <a:xfrm>
-            <a:off x="9692640" y="6303264"/>
+            <a:off x="9692640" y="7059168"/>
             <a:ext cx="7452360" cy="1441704"/>
           </a:xfrm>
           <a:prstGeom prst="roundRect">
@@ -19277,7 +19405,7 @@
         </p:nvSpPr>
         <p:spPr>
           <a:xfrm>
-            <a:off x="9966960" y="6394704"/>
+            <a:off x="9966960" y="7150607"/>
             <a:ext cx="6903720" cy="320040"/>
           </a:xfrm>
           <a:prstGeom prst="rect">
@@ -19312,7 +19440,7 @@
         </p:nvSpPr>
         <p:spPr>
           <a:xfrm>
-            <a:off x="9966960" y="6714744"/>
+            <a:off x="9966960" y="7470648"/>
             <a:ext cx="6903720" cy="984504"/>
           </a:xfrm>
           <a:prstGeom prst="rect">
@@ -19333,7 +19461,7 @@
                 </a:solidFill>
                 <a:latin typeface="Courier New"/>
               </a:rPr>
-              <a:t>['a', 'r', 'c', 'd']</a:t>
+              <a:t>[1200, 1600, 1000, 1800]</a:t>
             </a:r>
           </a:p>
           <a:p>
@@ -19344,7 +19472,7 @@
                 </a:solidFill>
                 <a:latin typeface="Courier New"/>
               </a:rPr>
-              <a:t>['a', 'r', 's', 't']</a:t>
+              <a:t>[1200, 1600, 1100, 1900]</a:t>
             </a:r>
           </a:p>
         </p:txBody>
@@ -19422,11 +19550,11 @@
                 </a:solidFill>
                 <a:latin typeface="Courier New"/>
               </a:rPr>
-              <a:t>y = x + ["e", "f"]</a:t>
+              <a:t>y = q + ["FY"]</a:t>
             </a:r>
             <a:r>
               <a:rPr sz="1800"/>
-              <a:t>  νέα λίστα, η x δεν αλλάζει</a:t>
+              <a:t>  νέα λίστα, η q δεν αλλάζει</a:t>
             </a:r>
           </a:p>
           <a:p>
@@ -19449,7 +19577,7 @@
                 </a:solidFill>
                 <a:latin typeface="Courier New"/>
               </a:rPr>
-              <a:t>del(x[1])</a:t>
+              <a:t>del(q[1])</a:t>
             </a:r>
             <a:r>
               <a:rPr sz="1800"/>
@@ -19483,7 +19611,7 @@
                 </a:solidFill>
                 <a:latin typeface="Courier New"/>
               </a:rPr>
-              <a:t>x.append("e")</a:t>
+              <a:t>q.append("FY")</a:t>
             </a:r>
             <a:r>
               <a:rPr sz="1800"/>
@@ -19611,7 +19739,7 @@
                 </a:solidFill>
                 <a:latin typeface="Courier New"/>
               </a:rPr>
-              <a:t>x = ["a", "b", "c", "d"]</a:t>
+              <a:t>q = ["Q1", "Q2", "Q3", "Q4"]</a:t>
             </a:r>
           </a:p>
           <a:p>
@@ -19622,13 +19750,22 @@
                 </a:solidFill>
                 <a:latin typeface="Courier New"/>
               </a:rPr>
-              <a:t>y = x + ["e", "f"]</a:t>
-            </a:r>
-          </a:p>
-          <a:p>
+              <a:t>y = q + ["FY"]   </a:t>
+            </a:r>
             <a:r>
               <a:rPr sz="1920">
                 <a:solidFill>
+                  <a:srgbClr val="9FB3E8"/>
+                </a:solidFill>
+                <a:latin typeface="Courier New"/>
+              </a:rPr>
+              <a:t># FY = όλο το έτος</a:t>
+            </a:r>
+          </a:p>
+          <a:p>
+            <a:r>
+              <a:rPr sz="1920">
+                <a:solidFill>
                   <a:srgbClr val="F4F6FF"/>
                 </a:solidFill>
                 <a:latin typeface="Courier New"/>
@@ -19655,7 +19792,7 @@
                 </a:solidFill>
                 <a:latin typeface="Courier New"/>
               </a:rPr>
-              <a:t>del(x[1])</a:t>
+              <a:t>del(q[1])</a:t>
             </a:r>
           </a:p>
           <a:p>
@@ -19666,7 +19803,7 @@
                 </a:solidFill>
                 <a:latin typeface="Courier New"/>
               </a:rPr>
-              <a:t>print(x)</a:t>
+              <a:t>print(q)</a:t>
             </a:r>
           </a:p>
           <a:p>
@@ -19688,7 +19825,7 @@
                 </a:solidFill>
                 <a:latin typeface="Courier New"/>
               </a:rPr>
-              <a:t>del(x[1:3])</a:t>
+              <a:t>del(q[1:3])</a:t>
             </a:r>
           </a:p>
           <a:p>
@@ -19699,7 +19836,7 @@
                 </a:solidFill>
                 <a:latin typeface="Courier New"/>
               </a:rPr>
-              <a:t>print(x)</a:t>
+              <a:t>print(q)</a:t>
             </a:r>
           </a:p>
         </p:txBody>
@@ -19825,7 +19962,7 @@
                 </a:solidFill>
                 <a:latin typeface="Courier New"/>
               </a:rPr>
-              <a:t>['a', 'b', 'c', 'd', 'e', 'f']</a:t>
+              <a:t>['Q1', 'Q2', 'Q3', 'Q4', 'FY']</a:t>
             </a:r>
           </a:p>
           <a:p>
@@ -19836,7 +19973,7 @@
                 </a:solidFill>
                 <a:latin typeface="Courier New"/>
               </a:rPr>
-              <a:t>['a', 'c', 'd']</a:t>
+              <a:t>['Q1', 'Q3', 'Q4']</a:t>
             </a:r>
           </a:p>
           <a:p>
@@ -19847,7 +19984,7 @@
                 </a:solidFill>
                 <a:latin typeface="Courier New"/>
               </a:rPr>
-              <a:t>['a']</a:t>
+              <a:t>['Q1']</a:t>
             </a:r>
           </a:p>
         </p:txBody>
@@ -19914,7 +20051,7 @@
                 </a:solidFill>
                 <a:latin typeface="Courier New"/>
               </a:rPr>
-              <a:t>y = x</a:t>
+              <a:t>backup = sales</a:t>
             </a:r>
             <a:r>
               <a:rPr sz="2200"/>
@@ -19925,14 +20062,14 @@
             <a:pPr lvl="1"/>
             <a:r>
               <a:rPr sz="1800"/>
-              <a:t>Τα x και y δείχνουν στην ίδια λίστα στη μνήμη</a:t>
+              <a:t>Τα sales και backup δείχνουν στην ίδια λίστα στη μνήμη</a:t>
             </a:r>
           </a:p>
           <a:p>
             <a:pPr lvl="1"/>
             <a:r>
               <a:rPr sz="1800"/>
-              <a:t>Αλλαγή μέσω του y φαίνεται και στο x</a:t>
+              <a:t>Αλλαγή μέσω του backup φαίνεται και στο sales</a:t>
             </a:r>
           </a:p>
           <a:p>
@@ -19955,7 +20092,7 @@
                 </a:solidFill>
                 <a:latin typeface="Courier New"/>
               </a:rPr>
-              <a:t>y = list(x)</a:t>
+              <a:t>backup = list(sales)</a:t>
             </a:r>
             <a:r>
               <a:rPr sz="1800"/>
@@ -19968,7 +20105,7 @@
                 </a:solidFill>
                 <a:latin typeface="Courier New"/>
               </a:rPr>
-              <a:t>y = x[:]</a:t>
+              <a:t>backup = sales[:]</a:t>
             </a:r>
           </a:p>
           <a:p>
@@ -20117,7 +20254,7 @@
                 </a:solidFill>
                 <a:latin typeface="Courier New"/>
               </a:rPr>
-              <a:t>x = ["a", "b", "c"]</a:t>
+              <a:t>sales = [1200, 1550, 1000]</a:t>
             </a:r>
           </a:p>
           <a:p>
@@ -20128,7 +20265,7 @@
                 </a:solidFill>
                 <a:latin typeface="Courier New"/>
               </a:rPr>
-              <a:t>y = x          </a:t>
+              <a:t>backup = sales          </a:t>
             </a:r>
             <a:r>
               <a:rPr sz="1920">
@@ -20148,7 +20285,7 @@
                 </a:solidFill>
                 <a:latin typeface="Courier New"/>
               </a:rPr>
-              <a:t>y[0] = "z"</a:t>
+              <a:t>backup[0] = 0</a:t>
             </a:r>
           </a:p>
           <a:p>
@@ -20159,7 +20296,7 @@
                 </a:solidFill>
                 <a:latin typeface="Courier New"/>
               </a:rPr>
-              <a:t>print(x)</a:t>
+              <a:t>print(sales)</a:t>
             </a:r>
           </a:p>
           <a:p>
@@ -20181,7 +20318,7 @@
                 </a:solidFill>
                 <a:latin typeface="Courier New"/>
               </a:rPr>
-              <a:t>x = ["a", "b", "c"]</a:t>
+              <a:t>sales = [1200, 1550, 1000]</a:t>
             </a:r>
           </a:p>
           <a:p>
@@ -20192,7 +20329,7 @@
                 </a:solidFill>
                 <a:latin typeface="Courier New"/>
               </a:rPr>
-              <a:t>y = list(x)    </a:t>
+              <a:t>backup = list(sales)    </a:t>
             </a:r>
             <a:r>
               <a:rPr sz="1920">
@@ -20212,7 +20349,7 @@
                 </a:solidFill>
                 <a:latin typeface="Courier New"/>
               </a:rPr>
-              <a:t>y[0] = "z"</a:t>
+              <a:t>backup[0] = 0</a:t>
             </a:r>
           </a:p>
           <a:p>
@@ -20223,7 +20360,7 @@
                 </a:solidFill>
                 <a:latin typeface="Courier New"/>
               </a:rPr>
-              <a:t>print(x)</a:t>
+              <a:t>print(sales)</a:t>
             </a:r>
           </a:p>
         </p:txBody>
@@ -20349,7 +20486,7 @@
                 </a:solidFill>
                 <a:latin typeface="Courier New"/>
               </a:rPr>
-              <a:t>['z', 'b', 'c']</a:t>
+              <a:t>[0, 1550, 1000]</a:t>
             </a:r>
           </a:p>
           <a:p>
@@ -20360,7 +20497,7 @@
                 </a:solidFill>
                 <a:latin typeface="Courier New"/>
               </a:rPr>
-              <a:t>['a', 'b', 'c']</a:t>
+              <a:t>[1200, 1550, 1000]</a:t>
             </a:r>
           </a:p>
         </p:txBody>
@@ -21852,21 +21989,21 @@
             <a:pPr lvl="1"/>
             <a:r>
               <a:rPr sz="1800"/>
-              <a:t>Τύπωσε τον τύπο της var1 με print() και type() μαζί</a:t>
+              <a:t>Τύπωσε τον τύπο της orders με print() και type() μαζί</a:t>
             </a:r>
           </a:p>
           <a:p>
             <a:pPr lvl="1"/>
             <a:r>
               <a:rPr sz="1800"/>
-              <a:t>Τύπωσε το μήκος της var1 με len()</a:t>
+              <a:t>Τύπωσε πόσες παραγγελίες έχει η orders με len()</a:t>
             </a:r>
           </a:p>
           <a:p>
             <a:pPr lvl="1"/>
             <a:r>
               <a:rPr sz="1800"/>
-              <a:t>Μετέτρεψε τη var2 σε ακέραιο με int() και αποθήκευσέ τον ως out2</a:t>
+              <a:t>Μετέτρεψε το is_vip σε ακέραιο με int() και αποθήκευσέ το ως vip_flag</a:t>
             </a:r>
           </a:p>
           <a:p>
@@ -22015,7 +22152,7 @@
                 </a:solidFill>
                 <a:latin typeface="Courier New"/>
               </a:rPr>
-              <a:t>var1 = [1, 2, 3, 4]</a:t>
+              <a:t>orders = [12, 7, 30, 5]</a:t>
             </a:r>
           </a:p>
           <a:p>
@@ -22026,7 +22163,7 @@
                 </a:solidFill>
                 <a:latin typeface="Courier New"/>
               </a:rPr>
-              <a:t>var2 = True</a:t>
+              <a:t>is_vip = True</a:t>
             </a:r>
           </a:p>
           <a:p>
@@ -22048,7 +22185,7 @@
                 </a:solidFill>
                 <a:latin typeface="Courier New"/>
               </a:rPr>
-              <a:t># Τύπος της var1</a:t>
+              <a:t># Τύπος της orders</a:t>
             </a:r>
           </a:p>
           <a:p>
@@ -22059,7 +22196,7 @@
                 </a:solidFill>
                 <a:latin typeface="Courier New"/>
               </a:rPr>
-              <a:t>print(type(var1))</a:t>
+              <a:t>print(type(orders))</a:t>
             </a:r>
           </a:p>
           <a:p>
@@ -22081,7 +22218,7 @@
                 </a:solidFill>
                 <a:latin typeface="Courier New"/>
               </a:rPr>
-              <a:t># Μήκος της var1</a:t>
+              <a:t># Πλήθος παραγγελιών</a:t>
             </a:r>
           </a:p>
           <a:p>
@@ -22092,7 +22229,7 @@
                 </a:solidFill>
                 <a:latin typeface="Courier New"/>
               </a:rPr>
-              <a:t>print(len(var1))</a:t>
+              <a:t>print(len(orders))</a:t>
             </a:r>
           </a:p>
           <a:p>
@@ -22114,7 +22251,7 @@
                 </a:solidFill>
                 <a:latin typeface="Courier New"/>
               </a:rPr>
-              <a:t># Μετατροπή της var2 σε int</a:t>
+              <a:t># Μετατροπή του is_vip σε int</a:t>
             </a:r>
           </a:p>
           <a:p>
@@ -22125,7 +22262,7 @@
                 </a:solidFill>
                 <a:latin typeface="Courier New"/>
               </a:rPr>
-              <a:t>out2 = int(var2)</a:t>
+              <a:t>vip_flag = int(is_vip)</a:t>
             </a:r>
           </a:p>
           <a:p>
@@ -22136,7 +22273,7 @@
                 </a:solidFill>
                 <a:latin typeface="Courier New"/>
               </a:rPr>
-              <a:t>print(out2)</a:t>
+              <a:t>print(vip_flag)</a:t>
             </a:r>
           </a:p>
         </p:txBody>
@@ -22410,7 +22547,7 @@
                 </a:solidFill>
                 <a:latin typeface="Courier New"/>
               </a:rPr>
-              <a:t>sorted(full, reverse=True)</a:t>
+              <a:t>sorted(total_sales, reverse=True)</a:t>
             </a:r>
             <a:r>
               <a:rPr sz="1700"/>
@@ -22554,7 +22691,7 @@
                 </a:solidFill>
                 <a:latin typeface="Courier New"/>
               </a:rPr>
-              <a:t>first = [11.25, 18.0, 20.0]</a:t>
+              <a:t>online = [1200, 1550, 1000]</a:t>
             </a:r>
           </a:p>
           <a:p>
@@ -22565,7 +22702,7 @@
                 </a:solidFill>
                 <a:latin typeface="Courier New"/>
               </a:rPr>
-              <a:t>second = [10.75, 9.50]</a:t>
+              <a:t>store = [980, 1310]</a:t>
             </a:r>
           </a:p>
           <a:p>
@@ -22598,7 +22735,7 @@
                 </a:solidFill>
                 <a:latin typeface="Courier New"/>
               </a:rPr>
-              <a:t>full = first + second</a:t>
+              <a:t>total_sales = online + store</a:t>
             </a:r>
           </a:p>
           <a:p>
@@ -22631,7 +22768,7 @@
                 </a:solidFill>
                 <a:latin typeface="Courier New"/>
               </a:rPr>
-              <a:t>full_sorted = sorted(full, reverse=True)</a:t>
+              <a:t>ranked = sorted(total_sales, reverse=True)</a:t>
             </a:r>
           </a:p>
           <a:p>
@@ -22642,7 +22779,7 @@
                 </a:solidFill>
                 <a:latin typeface="Courier New"/>
               </a:rPr>
-              <a:t>print(full_sorted)</a:t>
+              <a:t>print(ranked)</a:t>
             </a:r>
           </a:p>
         </p:txBody>
@@ -22768,7 +22905,7 @@
                 </a:solidFill>
                 <a:latin typeface="Courier New"/>
               </a:rPr>
-              <a:t>[20.0, 18.0, 11.25, 10.75, 9.5]</a:t>
+              <a:t>[1550, 1310, 1200, 1000, 980]</a:t>
             </a:r>
           </a:p>
         </p:txBody>
@@ -23112,7 +23249,7 @@
                 </a:solidFill>
                 <a:latin typeface="Courier New"/>
               </a:rPr>
-              <a:t>sister = "liz"</a:t>
+              <a:t>city = "thessaloniki"</a:t>
             </a:r>
           </a:p>
           <a:p>
@@ -23123,7 +23260,7 @@
                 </a:solidFill>
                 <a:latin typeface="Courier New"/>
               </a:rPr>
-              <a:t>print(sister.upper())</a:t>
+              <a:t>print(city.upper())</a:t>
             </a:r>
           </a:p>
           <a:p>
@@ -23134,7 +23271,7 @@
                 </a:solidFill>
                 <a:latin typeface="Courier New"/>
               </a:rPr>
-              <a:t>print(sister.count("z"))</a:t>
+              <a:t>print(city.count("s"))</a:t>
             </a:r>
           </a:p>
           <a:p>
@@ -23156,7 +23293,7 @@
                 </a:solidFill>
                 <a:latin typeface="Courier New"/>
               </a:rPr>
-              <a:t>fam = ["liz", 1.73, "emma", 1.68]</a:t>
+              <a:t>customers = ["anna", 1200.0, "nikos", 1550.0]</a:t>
             </a:r>
           </a:p>
           <a:p>
@@ -23167,7 +23304,7 @@
                 </a:solidFill>
                 <a:latin typeface="Courier New"/>
               </a:rPr>
-              <a:t>print(fam.index("emma"))</a:t>
+              <a:t>print(customers.index("nikos"))</a:t>
             </a:r>
           </a:p>
           <a:p>
@@ -23178,7 +23315,7 @@
                 </a:solidFill>
                 <a:latin typeface="Courier New"/>
               </a:rPr>
-              <a:t>print(fam.count(1.73))</a:t>
+              <a:t>print(customers.count(1200.0))</a:t>
             </a:r>
           </a:p>
           <a:p>
@@ -23200,7 +23337,7 @@
                 </a:solidFill>
                 <a:latin typeface="Courier New"/>
               </a:rPr>
-              <a:t>fam.append("anna")</a:t>
+              <a:t>customers.append("maria")</a:t>
             </a:r>
           </a:p>
           <a:p>
@@ -23211,7 +23348,7 @@
                 </a:solidFill>
                 <a:latin typeface="Courier New"/>
               </a:rPr>
-              <a:t>print(fam)</a:t>
+              <a:t>print(customers)</a:t>
             </a:r>
           </a:p>
         </p:txBody>
@@ -23337,7 +23474,7 @@
                 </a:solidFill>
                 <a:latin typeface="Courier New"/>
               </a:rPr>
-              <a:t>LIZ</a:t>
+              <a:t>THESSALONIKI</a:t>
             </a:r>
           </a:p>
           <a:p>
@@ -23348,6 +23485,28 @@
                 </a:solidFill>
                 <a:latin typeface="Courier New"/>
               </a:rPr>
+              <a:t>2</a:t>
+            </a:r>
+          </a:p>
+          <a:p>
+            <a:r>
+              <a:rPr sz="1680">
+                <a:solidFill>
+                  <a:srgbClr val="1B2F6B"/>
+                </a:solidFill>
+                <a:latin typeface="Courier New"/>
+              </a:rPr>
+              <a:t>2</a:t>
+            </a:r>
+          </a:p>
+          <a:p>
+            <a:r>
+              <a:rPr sz="1680">
+                <a:solidFill>
+                  <a:srgbClr val="1B2F6B"/>
+                </a:solidFill>
+                <a:latin typeface="Courier New"/>
+              </a:rPr>
               <a:t>1</a:t>
             </a:r>
           </a:p>
@@ -23359,29 +23518,7 @@
                 </a:solidFill>
                 <a:latin typeface="Courier New"/>
               </a:rPr>
-              <a:t>2</a:t>
-            </a:r>
-          </a:p>
-          <a:p>
-            <a:r>
-              <a:rPr sz="1680">
-                <a:solidFill>
-                  <a:srgbClr val="1B2F6B"/>
-                </a:solidFill>
-                <a:latin typeface="Courier New"/>
-              </a:rPr>
-              <a:t>1</a:t>
-            </a:r>
-          </a:p>
-          <a:p>
-            <a:r>
-              <a:rPr sz="1680">
-                <a:solidFill>
-                  <a:srgbClr val="1B2F6B"/>
-                </a:solidFill>
-                <a:latin typeface="Courier New"/>
-              </a:rPr>
-              <a:t>['liz', 1.73, 'emma', 1.68, 'anna']</a:t>
+              <a:t>['anna', 1200.0, 'nikos', 1550.0, 'maria']</a:t>
             </a:r>
           </a:p>
         </p:txBody>
@@ -23561,7 +23698,7 @@
                 </a:solidFill>
                 <a:latin typeface="Courier New"/>
               </a:rPr>
-              <a:t>len(fam)</a:t>
+              <a:t>len(customers)</a:t>
             </a:r>
           </a:p>
           <a:p>
@@ -23631,7 +23768,7 @@
                 </a:solidFill>
                 <a:latin typeface="Courier New"/>
               </a:rPr>
-              <a:t>fam.index("emma")</a:t>
+              <a:t>customers.index("nikos")</a:t>
             </a:r>
           </a:p>
           <a:p>
@@ -23767,7 +23904,7 @@
                 </a:solidFill>
                 <a:latin typeface="Arial"/>
               </a:rPr>
-              <a:t>fam = fam.append("anna")  κάνει τη fam ίση με None, γιατί η append() δεν επιστρέφει τίποτα. Γράψε απλώς fam.append("anna").</a:t>
+              <a:t>customers = customers.append("maria")  κάνει τη customers ίση με None, γιατί η append() δεν επιστρέφει τίποτα. Γράψε απλώς customers.append("maria").</a:t>
             </a:r>
           </a:p>
         </p:txBody>
@@ -24912,7 +25049,7 @@
                 </a:solidFill>
                 <a:latin typeface="Courier New"/>
               </a:rPr>
-              <a:t>heights = [1.73, 1.68, 1.71, 1.89]</a:t>
+              <a:t>prices = [19.9, 249.0, 45.0, 59.0]</a:t>
             </a:r>
           </a:p>
           <a:p>
@@ -24923,7 +25060,7 @@
                 </a:solidFill>
                 <a:latin typeface="Courier New"/>
               </a:rPr>
-              <a:t>np_heights = np.array(heights)</a:t>
+              <a:t>np_prices = np.array(prices)</a:t>
             </a:r>
           </a:p>
           <a:p>
@@ -24945,7 +25082,7 @@
                 </a:solidFill>
                 <a:latin typeface="Courier New"/>
               </a:rPr>
-              <a:t>print(np_heights * 100)   </a:t>
+              <a:t>print(np_prices * 1.24)   </a:t>
             </a:r>
             <a:r>
               <a:rPr sz="1800">
@@ -24954,7 +25091,7 @@
                 </a:solidFill>
                 <a:latin typeface="Courier New"/>
               </a:rPr>
-              <a:t># σε εκατοστά</a:t>
+              <a:t># με ΦΠΑ 24%</a:t>
             </a:r>
           </a:p>
           <a:p>
@@ -24976,7 +25113,7 @@
                 </a:solidFill>
                 <a:latin typeface="Courier New"/>
               </a:rPr>
-              <a:t>from math import pi</a:t>
+              <a:t>from math import ceil</a:t>
             </a:r>
           </a:p>
           <a:p>
@@ -24987,7 +25124,16 @@
                 </a:solidFill>
                 <a:latin typeface="Courier New"/>
               </a:rPr>
-              <a:t>print(pi)</a:t>
+              <a:t>print(ceil(1250 / 48))   </a:t>
+            </a:r>
+            <a:r>
+              <a:rPr sz="1800">
+                <a:solidFill>
+                  <a:srgbClr val="9FB3E8"/>
+                </a:solidFill>
+                <a:latin typeface="Courier New"/>
+              </a:rPr>
+              <a:t># κουτιά των 48</a:t>
             </a:r>
           </a:p>
         </p:txBody>
@@ -25113,7 +25259,7 @@
                 </a:solidFill>
                 <a:latin typeface="Courier New"/>
               </a:rPr>
-              <a:t>[173. 168. 171. 189.]</a:t>
+              <a:t>[ 24.676 308.76   55.8    73.16 ]</a:t>
             </a:r>
           </a:p>
           <a:p>
@@ -25124,7 +25270,7 @@
                 </a:solidFill>
                 <a:latin typeface="Courier New"/>
               </a:rPr>
-              <a:t>3.141592653589793</a:t>
+              <a:t>27</a:t>
             </a:r>
           </a:p>
         </p:txBody>
@@ -25392,7 +25538,7 @@
                 </a:solidFill>
                 <a:latin typeface="Arial"/>
               </a:rPr>
-              <a:t>Χρησιμοποιείς όνομα που δεν έχει οριστεί (ή το έγραψες αλλιώς: savings vs Savings).</a:t>
+              <a:t>Χρησιμοποιείς όνομα που δεν έχει οριστεί (ή το έγραψες αλλιώς: revenue vs Revenue).</a:t>
             </a:r>
           </a:p>
           <a:p>
@@ -25408,7 +25554,7 @@
                 </a:solidFill>
                 <a:latin typeface="Courier New"/>
               </a:rPr>
-              <a:t>print(saving)  # λείπει το s</a:t>
+              <a:t>print(revenu)  # λείπει το e</a:t>
             </a:r>
           </a:p>
         </p:txBody>
@@ -26118,7 +26264,7 @@
                 </a:solidFill>
                 <a:latin typeface="Courier New"/>
               </a:rPr>
-              <a:t>savings = 100</a:t>
+              <a:t>revenue = 1250</a:t>
             </a:r>
           </a:p>
           <a:p>
@@ -26129,7 +26275,7 @@
                 </a:solidFill>
                 <a:latin typeface="Courier New"/>
               </a:rPr>
-              <a:t>label = "Savings: "</a:t>
+              <a:t>label = "Revenue: "</a:t>
             </a:r>
           </a:p>
           <a:p>
@@ -26140,7 +26286,7 @@
                 </a:solidFill>
                 <a:latin typeface="Courier New"/>
               </a:rPr>
-              <a:t>print(label + savings)</a:t>
+              <a:t>print(label + revenue)</a:t>
             </a:r>
           </a:p>
         </p:txBody>
@@ -26288,7 +26434,7 @@
                 </a:solidFill>
                 <a:latin typeface="Courier New"/>
               </a:rPr>
-              <a:t>    print(label + savings)</a:t>
+              <a:t>    print(label + revenue)</a:t>
             </a:r>
           </a:p>
           <a:p>

</xml_diff>